<commit_message>
Add datatable export buttons
</commit_message>
<xml_diff>
--- a/.lessons/34 Packages Yajra Datatable/3 Getting Started with Yajra Datatable/1.pptx
+++ b/.lessons/34 Packages Yajra Datatable/3 Getting Started with Yajra Datatable/1.pptx
@@ -21,8 +21,17 @@
     <p:sldId id="414" r:id="rId15"/>
     <p:sldId id="415" r:id="rId16"/>
     <p:sldId id="416" r:id="rId17"/>
-    <p:sldId id="417" r:id="rId18"/>
-    <p:sldId id="418" r:id="rId19"/>
+    <p:sldId id="419" r:id="rId18"/>
+    <p:sldId id="420" r:id="rId19"/>
+    <p:sldId id="421" r:id="rId20"/>
+    <p:sldId id="422" r:id="rId21"/>
+    <p:sldId id="423" r:id="rId22"/>
+    <p:sldId id="424" r:id="rId23"/>
+    <p:sldId id="425" r:id="rId24"/>
+    <p:sldId id="426" r:id="rId25"/>
+    <p:sldId id="427" r:id="rId26"/>
+    <p:sldId id="417" r:id="rId27"/>
+    <p:sldId id="418" r:id="rId28"/>
   </p:sldIdLst>
   <p:sldSz cx="12192000" cy="6858000"/>
   <p:notesSz cx="6858000" cy="9144000"/>
@@ -3733,7 +3742,7 @@
         <p:spPr>
           <a:xfrm>
             <a:off x="217714" y="255046"/>
-            <a:ext cx="11756571" cy="355354"/>
+            <a:ext cx="11756571" cy="1855764"/>
           </a:xfrm>
           <a:prstGeom prst="rect">
             <a:avLst/>
@@ -3753,7 +3762,143 @@
               <a:buNone/>
             </a:pPr>
             <a:r>
-              <a:rPr kumimoji="0" lang="en-US" altLang="en-US" sz="1300" b="0" i="0" u="none" strike="noStrike" cap="none" normalizeH="0" baseline="0">
+              <a:rPr lang="en-US" altLang="en-US" sz="1300" b="1">
+                <a:latin typeface="Arial" panose="020B0604020202020204" pitchFamily="34" charset="0"/>
+              </a:rPr>
+              <a:t>Yajra DataTables </a:t>
+            </a:r>
+            <a:r>
+              <a:rPr lang="en-US" altLang="en-US" sz="1300">
+                <a:latin typeface="Arial" panose="020B0604020202020204" pitchFamily="34" charset="0"/>
+              </a:rPr>
+              <a:t>üçün əlavə edilən </a:t>
+            </a:r>
+            <a:r>
+              <a:rPr lang="en-US" altLang="en-US" sz="1300" b="1">
+                <a:latin typeface="Arial" panose="020B0604020202020204" pitchFamily="34" charset="0"/>
+              </a:rPr>
+              <a:t>CSS</a:t>
+            </a:r>
+            <a:r>
+              <a:rPr lang="en-US" altLang="en-US" sz="1300">
+                <a:latin typeface="Arial" panose="020B0604020202020204" pitchFamily="34" charset="0"/>
+              </a:rPr>
+              <a:t> və </a:t>
+            </a:r>
+            <a:r>
+              <a:rPr lang="en-US" altLang="en-US" sz="1300" b="1">
+                <a:latin typeface="Arial" panose="020B0604020202020204" pitchFamily="34" charset="0"/>
+              </a:rPr>
+              <a:t>JS</a:t>
+            </a:r>
+            <a:r>
+              <a:rPr lang="en-US" altLang="en-US" sz="1300">
+                <a:latin typeface="Arial" panose="020B0604020202020204" pitchFamily="34" charset="0"/>
+              </a:rPr>
+              <a:t> </a:t>
+            </a:r>
+            <a:r>
+              <a:rPr lang="en-US" altLang="en-US" sz="1300" b="1">
+                <a:latin typeface="Arial" panose="020B0604020202020204" pitchFamily="34" charset="0"/>
+              </a:rPr>
+              <a:t>fayllarının</a:t>
+            </a:r>
+            <a:r>
+              <a:rPr lang="en-US" altLang="en-US" sz="1300">
+                <a:latin typeface="Arial" panose="020B0604020202020204" pitchFamily="34" charset="0"/>
+              </a:rPr>
+              <a:t> digər səhifələrdə, məsələn </a:t>
+            </a:r>
+            <a:r>
+              <a:rPr lang="en-US" altLang="en-US" sz="1300" b="1">
+                <a:latin typeface="Arial" panose="020B0604020202020204" pitchFamily="34" charset="0"/>
+              </a:rPr>
+              <a:t>login, register, forgot password </a:t>
+            </a:r>
+            <a:r>
+              <a:rPr lang="en-US" altLang="en-US" sz="1300">
+                <a:latin typeface="Arial" panose="020B0604020202020204" pitchFamily="34" charset="0"/>
+              </a:rPr>
+              <a:t>kimi səhifələrdə dizaynı (interfeysi) pozmasıdır. Bu problem çox yayğındır və əsas səbəb </a:t>
+            </a:r>
+            <a:r>
+              <a:rPr lang="en-US" altLang="en-US" sz="1300" b="1">
+                <a:latin typeface="Arial" panose="020B0604020202020204" pitchFamily="34" charset="0"/>
+              </a:rPr>
+              <a:t>DataTables</a:t>
+            </a:r>
+            <a:r>
+              <a:rPr lang="en-US" altLang="en-US" sz="1300">
+                <a:latin typeface="Arial" panose="020B0604020202020204" pitchFamily="34" charset="0"/>
+              </a:rPr>
+              <a:t> və </a:t>
+            </a:r>
+            <a:r>
+              <a:rPr lang="en-US" altLang="en-US" sz="1300" b="1">
+                <a:latin typeface="Arial" panose="020B0604020202020204" pitchFamily="34" charset="0"/>
+              </a:rPr>
+              <a:t>Bootstrap</a:t>
+            </a:r>
+            <a:r>
+              <a:rPr lang="en-US" altLang="en-US" sz="1300">
+                <a:latin typeface="Arial" panose="020B0604020202020204" pitchFamily="34" charset="0"/>
+              </a:rPr>
+              <a:t>-ın bütün sayta yüklənməsidir. </a:t>
+            </a:r>
+            <a:r>
+              <a:rPr lang="en-US" altLang="en-US" sz="1300" b="1">
+                <a:latin typeface="Arial" panose="020B0604020202020204" pitchFamily="34" charset="0"/>
+              </a:rPr>
+              <a:t>Laravel + Vite </a:t>
+            </a:r>
+            <a:r>
+              <a:rPr lang="en-US" altLang="en-US" sz="1300">
+                <a:latin typeface="Arial" panose="020B0604020202020204" pitchFamily="34" charset="0"/>
+              </a:rPr>
+              <a:t>istifadə edənlər üçün bu problemi dinamik yükləmə və səhifəyə görə fayl əlavə etmə üsulu ilə tam həll etmək mümkündür.</a:t>
+            </a:r>
+            <a:endParaRPr lang="az-Latn-AZ" altLang="en-US" sz="1300">
+              <a:latin typeface="Arial" panose="020B0604020202020204" pitchFamily="34" charset="0"/>
+            </a:endParaRPr>
+          </a:p>
+          <a:p>
+            <a:pPr>
+              <a:lnSpc>
+                <a:spcPct val="150000"/>
+              </a:lnSpc>
+              <a:buNone/>
+            </a:pPr>
+            <a:endParaRPr kumimoji="0" lang="az-Latn-AZ" altLang="en-US" sz="1300" b="0" i="0" u="none" strike="noStrike" cap="none" normalizeH="0" baseline="0">
+              <a:ln>
+                <a:noFill/>
+              </a:ln>
+              <a:solidFill>
+                <a:schemeClr val="tx1"/>
+              </a:solidFill>
+              <a:effectLst/>
+              <a:latin typeface="Arial" panose="020B0604020202020204" pitchFamily="34" charset="0"/>
+            </a:endParaRPr>
+          </a:p>
+          <a:p>
+            <a:pPr>
+              <a:lnSpc>
+                <a:spcPct val="150000"/>
+              </a:lnSpc>
+              <a:buNone/>
+            </a:pPr>
+            <a:endParaRPr lang="az-Latn-AZ" altLang="en-US" sz="1300">
+              <a:latin typeface="Arial" panose="020B0604020202020204" pitchFamily="34" charset="0"/>
+            </a:endParaRPr>
+          </a:p>
+          <a:p>
+            <a:pPr>
+              <a:lnSpc>
+                <a:spcPct val="150000"/>
+              </a:lnSpc>
+              <a:buNone/>
+            </a:pPr>
+            <a:r>
+              <a:rPr kumimoji="0" lang="az-Latn-AZ" altLang="en-US" sz="1300" b="0" i="0" u="none" strike="noStrike" cap="none" normalizeH="0" baseline="0">
                 <a:ln>
                   <a:noFill/>
                 </a:ln>
@@ -3763,11 +3908,97 @@
                 <a:effectLst/>
                 <a:latin typeface="Arial" panose="020B0604020202020204" pitchFamily="34" charset="0"/>
               </a:rPr>
-              <a:t>.</a:t>
-            </a:r>
+              <a:t>Mən indi heçnə etməyəcəm, sadəcə </a:t>
+            </a:r>
+            <a:r>
+              <a:rPr kumimoji="0" lang="az-Latn-AZ" altLang="en-US" sz="1300" b="1" i="0" u="none" strike="noStrike" cap="none" normalizeH="0" baseline="0">
+                <a:ln>
+                  <a:noFill/>
+                </a:ln>
+                <a:solidFill>
+                  <a:srgbClr val="FF0000"/>
+                </a:solidFill>
+                <a:effectLst/>
+                <a:latin typeface="Arial" panose="020B0604020202020204" pitchFamily="34" charset="0"/>
+              </a:rPr>
+              <a:t>npm run dev </a:t>
+            </a:r>
+            <a:r>
+              <a:rPr kumimoji="0" lang="az-Latn-AZ" altLang="en-US" sz="1300" b="0" i="0" u="none" strike="noStrike" cap="none" normalizeH="0" baseline="0">
+                <a:ln>
+                  <a:noFill/>
+                </a:ln>
+                <a:solidFill>
+                  <a:schemeClr val="tx1"/>
+                </a:solidFill>
+                <a:effectLst/>
+                <a:latin typeface="Arial" panose="020B0604020202020204" pitchFamily="34" charset="0"/>
+              </a:rPr>
+              <a:t>yazaraq proqramı işə salanda düzəlir</a:t>
+            </a:r>
+            <a:r>
+              <a:rPr lang="az-Latn-AZ" altLang="en-US" sz="1300">
+                <a:latin typeface="Arial" panose="020B0604020202020204" pitchFamily="34" charset="0"/>
+              </a:rPr>
+              <a:t> problem.</a:t>
+            </a:r>
+            <a:endParaRPr kumimoji="0" lang="en-US" altLang="en-US" sz="1300" b="0" i="0" u="none" strike="noStrike" cap="none" normalizeH="0" baseline="0">
+              <a:ln>
+                <a:noFill/>
+              </a:ln>
+              <a:solidFill>
+                <a:schemeClr val="tx1"/>
+              </a:solidFill>
+              <a:effectLst/>
+              <a:latin typeface="Arial" panose="020B0604020202020204" pitchFamily="34" charset="0"/>
+            </a:endParaRPr>
           </a:p>
         </p:txBody>
       </p:sp>
+      <p:pic>
+        <p:nvPicPr>
+          <p:cNvPr id="5" name="Picture 4">
+            <a:extLst>
+              <a:ext uri="{FF2B5EF4-FFF2-40B4-BE49-F238E27FC236}">
+                <a16:creationId xmlns:a16="http://schemas.microsoft.com/office/drawing/2014/main" id="{E25A8C58-4807-5930-95B7-5220C9B0A033}"/>
+              </a:ext>
+            </a:extLst>
+          </p:cNvPr>
+          <p:cNvPicPr>
+            <a:picLocks noChangeAspect="1"/>
+          </p:cNvPicPr>
+          <p:nvPr/>
+        </p:nvPicPr>
+        <p:blipFill>
+          <a:blip r:embed="rId2"/>
+          <a:stretch>
+            <a:fillRect/>
+          </a:stretch>
+        </p:blipFill>
+        <p:spPr>
+          <a:xfrm>
+            <a:off x="7913062" y="1483567"/>
+            <a:ext cx="4278938" cy="5374433"/>
+          </a:xfrm>
+          <a:prstGeom prst="rect">
+            <a:avLst/>
+          </a:prstGeom>
+          <a:ln w="38100" cap="sq">
+            <a:solidFill>
+              <a:srgbClr val="000000"/>
+            </a:solidFill>
+            <a:prstDash val="solid"/>
+            <a:miter lim="800000"/>
+          </a:ln>
+          <a:effectLst>
+            <a:outerShdw blurRad="50800" dist="38100" dir="2700000" algn="tl" rotWithShape="0">
+              <a:srgbClr val="000000">
+                <a:alpha val="43000"/>
+              </a:srgbClr>
+            </a:outerShdw>
+          </a:effectLst>
+        </p:spPr>
+      </p:pic>
     </p:spTree>
     <p:extLst>
       <p:ext uri="{BB962C8B-B14F-4D97-AF65-F5344CB8AC3E}">
@@ -3819,7 +4050,7 @@
         <p:spPr>
           <a:xfrm>
             <a:off x="217714" y="255046"/>
-            <a:ext cx="11756571" cy="355354"/>
+            <a:ext cx="11756571" cy="955518"/>
           </a:xfrm>
           <a:prstGeom prst="rect">
             <a:avLst/>
@@ -3839,21 +4070,106 @@
               <a:buNone/>
             </a:pPr>
             <a:r>
-              <a:rPr kumimoji="0" lang="en-US" altLang="en-US" sz="1300" b="0" i="0" u="none" strike="noStrike" cap="none" normalizeH="0" baseline="0">
-                <a:ln>
-                  <a:noFill/>
-                </a:ln>
-                <a:solidFill>
-                  <a:schemeClr val="tx1"/>
-                </a:solidFill>
-                <a:effectLst/>
-                <a:latin typeface="Arial" panose="020B0604020202020204" pitchFamily="34" charset="0"/>
-              </a:rPr>
-              <a:t>.</a:t>
-            </a:r>
+              <a:rPr lang="az-Latn-AZ" altLang="en-US" sz="1300">
+                <a:latin typeface="Arial" panose="020B0604020202020204" pitchFamily="34" charset="0"/>
+              </a:rPr>
+              <a:t>İndi də, şablona şəkildə gördüyünüz kimi </a:t>
+            </a:r>
+            <a:r>
+              <a:rPr lang="az-Latn-AZ" altLang="en-US" sz="1300" b="1">
+                <a:latin typeface="Arial" panose="020B0604020202020204" pitchFamily="34" charset="0"/>
+              </a:rPr>
+              <a:t>Button</a:t>
+            </a:r>
+            <a:r>
+              <a:rPr lang="az-Latn-AZ" altLang="en-US" sz="1300">
+                <a:latin typeface="Arial" panose="020B0604020202020204" pitchFamily="34" charset="0"/>
+              </a:rPr>
+              <a:t> -lar əlavə edəcəyik. Növbəti slayd....</a:t>
+            </a:r>
+          </a:p>
+          <a:p>
+            <a:pPr>
+              <a:lnSpc>
+                <a:spcPct val="150000"/>
+              </a:lnSpc>
+              <a:buNone/>
+            </a:pPr>
+            <a:endParaRPr kumimoji="0" lang="az-Latn-AZ" altLang="en-US" sz="1300" b="0" i="0" u="none" strike="noStrike" cap="none" normalizeH="0" baseline="0">
+              <a:ln>
+                <a:noFill/>
+              </a:ln>
+              <a:solidFill>
+                <a:schemeClr val="tx1"/>
+              </a:solidFill>
+              <a:effectLst/>
+              <a:latin typeface="Arial" panose="020B0604020202020204" pitchFamily="34" charset="0"/>
+            </a:endParaRPr>
+          </a:p>
+          <a:p>
+            <a:pPr>
+              <a:lnSpc>
+                <a:spcPct val="150000"/>
+              </a:lnSpc>
+              <a:buNone/>
+            </a:pPr>
+            <a:endParaRPr kumimoji="0" lang="en-US" altLang="en-US" sz="1300" b="0" i="0" u="none" strike="noStrike" cap="none" normalizeH="0" baseline="0">
+              <a:ln>
+                <a:noFill/>
+              </a:ln>
+              <a:solidFill>
+                <a:schemeClr val="tx1"/>
+              </a:solidFill>
+              <a:effectLst/>
+              <a:latin typeface="Arial" panose="020B0604020202020204" pitchFamily="34" charset="0"/>
+            </a:endParaRPr>
           </a:p>
         </p:txBody>
       </p:sp>
+      <p:pic>
+        <p:nvPicPr>
+          <p:cNvPr id="4" name="Picture 3">
+            <a:extLst>
+              <a:ext uri="{FF2B5EF4-FFF2-40B4-BE49-F238E27FC236}">
+                <a16:creationId xmlns:a16="http://schemas.microsoft.com/office/drawing/2014/main" id="{16471795-0C8B-66A0-0323-26F250538E94}"/>
+              </a:ext>
+            </a:extLst>
+          </p:cNvPr>
+          <p:cNvPicPr>
+            <a:picLocks noChangeAspect="1"/>
+          </p:cNvPicPr>
+          <p:nvPr/>
+        </p:nvPicPr>
+        <p:blipFill>
+          <a:blip r:embed="rId2"/>
+          <a:stretch>
+            <a:fillRect/>
+          </a:stretch>
+        </p:blipFill>
+        <p:spPr>
+          <a:xfrm>
+            <a:off x="4084786" y="2520756"/>
+            <a:ext cx="7889499" cy="4250149"/>
+          </a:xfrm>
+          <a:prstGeom prst="rect">
+            <a:avLst/>
+          </a:prstGeom>
+          <a:ln w="38100" cap="sq">
+            <a:solidFill>
+              <a:srgbClr val="000000"/>
+            </a:solidFill>
+            <a:prstDash val="solid"/>
+            <a:miter lim="800000"/>
+          </a:ln>
+          <a:effectLst>
+            <a:outerShdw blurRad="50800" dist="38100" dir="2700000" algn="tl" rotWithShape="0">
+              <a:srgbClr val="000000">
+                <a:alpha val="43000"/>
+              </a:srgbClr>
+            </a:outerShdw>
+          </a:effectLst>
+        </p:spPr>
+      </p:pic>
     </p:spTree>
     <p:extLst>
       <p:ext uri="{BB962C8B-B14F-4D97-AF65-F5344CB8AC3E}">
@@ -3904,8 +4220,8 @@
         </p:nvSpPr>
         <p:spPr>
           <a:xfrm>
-            <a:off x="217714" y="255046"/>
-            <a:ext cx="11756571" cy="355354"/>
+            <a:off x="217714" y="55986"/>
+            <a:ext cx="11756571" cy="612155"/>
           </a:xfrm>
           <a:prstGeom prst="rect">
             <a:avLst/>
@@ -3925,21 +4241,120 @@
               <a:buNone/>
             </a:pPr>
             <a:r>
-              <a:rPr kumimoji="0" lang="en-US" altLang="en-US" sz="1300" b="0" i="0" u="none" strike="noStrike" cap="none" normalizeH="0" baseline="0">
-                <a:ln>
-                  <a:noFill/>
-                </a:ln>
-                <a:solidFill>
-                  <a:schemeClr val="tx1"/>
-                </a:solidFill>
-                <a:effectLst/>
-                <a:latin typeface="Arial" panose="020B0604020202020204" pitchFamily="34" charset="0"/>
-              </a:rPr>
-              <a:t>.</a:t>
-            </a:r>
+              <a:rPr lang="az-Latn-AZ" altLang="en-US" sz="1200" b="1">
+                <a:latin typeface="Arial" panose="020B0604020202020204" pitchFamily="34" charset="0"/>
+              </a:rPr>
+              <a:t>UserDataTable.php </a:t>
+            </a:r>
+            <a:r>
+              <a:rPr lang="az-Latn-AZ" altLang="en-US" sz="1200">
+                <a:latin typeface="Arial" panose="020B0604020202020204" pitchFamily="34" charset="0"/>
+              </a:rPr>
+              <a:t>faylındakı işarələnən hissələr commentdə idi. Həmin hissələri commentdən çıxardırıq. `</a:t>
+            </a:r>
+            <a:r>
+              <a:rPr lang="az-Latn-AZ" altLang="en-US" sz="1200" b="1">
+                <a:latin typeface="Arial" panose="020B0604020202020204" pitchFamily="34" charset="0"/>
+              </a:rPr>
+              <a:t>app.css</a:t>
+            </a:r>
+            <a:r>
+              <a:rPr lang="az-Latn-AZ" altLang="en-US" sz="1200">
+                <a:latin typeface="Arial" panose="020B0604020202020204" pitchFamily="34" charset="0"/>
+              </a:rPr>
+              <a:t>` faylındakı </a:t>
+            </a:r>
+            <a:r>
+              <a:rPr lang="az-Latn-AZ" altLang="en-US" sz="1200" b="1">
+                <a:latin typeface="Arial" panose="020B0604020202020204" pitchFamily="34" charset="0"/>
+              </a:rPr>
+              <a:t>İmportları</a:t>
+            </a:r>
+            <a:r>
+              <a:rPr lang="az-Latn-AZ" altLang="en-US" sz="1200">
+                <a:latin typeface="Arial" panose="020B0604020202020204" pitchFamily="34" charset="0"/>
+              </a:rPr>
+              <a:t> yuxarı daşıyırıq və `</a:t>
+            </a:r>
+            <a:r>
+              <a:rPr lang="en-US" altLang="en-US" sz="1200" b="1">
+                <a:latin typeface="Arial" panose="020B0604020202020204" pitchFamily="34" charset="0"/>
+              </a:rPr>
+              <a:t>resources\views\layouts\app.blade.php</a:t>
+            </a:r>
+            <a:r>
+              <a:rPr lang="az-Latn-AZ" altLang="en-US" sz="1200">
+                <a:latin typeface="Arial" panose="020B0604020202020204" pitchFamily="34" charset="0"/>
+              </a:rPr>
+              <a:t>` faylında isə, </a:t>
+            </a:r>
+            <a:r>
+              <a:rPr lang="az-Latn-AZ" altLang="en-US" sz="1200" b="1">
+                <a:latin typeface="Arial" panose="020B0604020202020204" pitchFamily="34" charset="0"/>
+              </a:rPr>
+              <a:t>bootstrap</a:t>
+            </a:r>
+            <a:r>
+              <a:rPr lang="az-Latn-AZ" altLang="en-US" sz="1200">
+                <a:latin typeface="Arial" panose="020B0604020202020204" pitchFamily="34" charset="0"/>
+              </a:rPr>
+              <a:t> -in </a:t>
+            </a:r>
+            <a:r>
+              <a:rPr lang="az-Latn-AZ" altLang="en-US" sz="1200" b="1">
+                <a:latin typeface="Arial" panose="020B0604020202020204" pitchFamily="34" charset="0"/>
+              </a:rPr>
+              <a:t>icon</a:t>
+            </a:r>
+            <a:r>
+              <a:rPr lang="az-Latn-AZ" altLang="en-US" sz="1200">
+                <a:latin typeface="Arial" panose="020B0604020202020204" pitchFamily="34" charset="0"/>
+              </a:rPr>
+              <a:t> linkini yerləşdiririk. </a:t>
+            </a:r>
+            <a:endParaRPr kumimoji="0" lang="en-US" altLang="en-US" sz="1200" b="0" i="0" u="none" strike="noStrike" cap="none" normalizeH="0" baseline="0">
+              <a:ln>
+                <a:noFill/>
+              </a:ln>
+              <a:solidFill>
+                <a:schemeClr val="tx1"/>
+              </a:solidFill>
+              <a:effectLst/>
+              <a:latin typeface="Arial" panose="020B0604020202020204" pitchFamily="34" charset="0"/>
+            </a:endParaRPr>
           </a:p>
         </p:txBody>
       </p:sp>
+      <p:pic>
+        <p:nvPicPr>
+          <p:cNvPr id="4" name="Picture 3">
+            <a:extLst>
+              <a:ext uri="{FF2B5EF4-FFF2-40B4-BE49-F238E27FC236}">
+                <a16:creationId xmlns:a16="http://schemas.microsoft.com/office/drawing/2014/main" id="{19601B1A-FE7E-8CAC-D47E-5DE4ED0B61B7}"/>
+              </a:ext>
+            </a:extLst>
+          </p:cNvPr>
+          <p:cNvPicPr>
+            <a:picLocks noChangeAspect="1"/>
+          </p:cNvPicPr>
+          <p:nvPr/>
+        </p:nvPicPr>
+        <p:blipFill>
+          <a:blip r:embed="rId2"/>
+          <a:stretch>
+            <a:fillRect/>
+          </a:stretch>
+        </p:blipFill>
+        <p:spPr>
+          <a:xfrm>
+            <a:off x="0" y="726199"/>
+            <a:ext cx="12192000" cy="6131801"/>
+          </a:xfrm>
+          <a:prstGeom prst="rect">
+            <a:avLst/>
+          </a:prstGeom>
+        </p:spPr>
+      </p:pic>
     </p:spTree>
     <p:extLst>
       <p:ext uri="{BB962C8B-B14F-4D97-AF65-F5344CB8AC3E}">
@@ -3991,7 +4406,7 @@
         <p:spPr>
           <a:xfrm>
             <a:off x="217714" y="255046"/>
-            <a:ext cx="11756571" cy="355354"/>
+            <a:ext cx="11756571" cy="1971181"/>
           </a:xfrm>
           <a:prstGeom prst="rect">
             <a:avLst/>
@@ -4011,7 +4426,63 @@
               <a:buNone/>
             </a:pPr>
             <a:r>
-              <a:rPr kumimoji="0" lang="en-US" altLang="en-US" sz="1300" b="0" i="0" u="none" strike="noStrike" cap="none" normalizeH="0" baseline="0">
+              <a:rPr lang="az-Latn-AZ" altLang="en-US" sz="1300">
+                <a:latin typeface="Arial" panose="020B0604020202020204" pitchFamily="34" charset="0"/>
+              </a:rPr>
+              <a:t>Əslində icon -lar üçün əlavə link yerləşdirməyə ehtiyac yox idi, çünki `app.css` faylında yazdığımız İMPORT -ların içində belə bir kod var: </a:t>
+            </a:r>
+          </a:p>
+          <a:p>
+            <a:pPr>
+              <a:lnSpc>
+                <a:spcPct val="150000"/>
+              </a:lnSpc>
+              <a:buNone/>
+            </a:pPr>
+            <a:endParaRPr lang="az-Latn-AZ" altLang="en-US" sz="1300">
+              <a:latin typeface="Arial" panose="020B0604020202020204" pitchFamily="34" charset="0"/>
+            </a:endParaRPr>
+          </a:p>
+          <a:p>
+            <a:pPr marL="742950" lvl="1" indent="-285750">
+              <a:lnSpc>
+                <a:spcPct val="150000"/>
+              </a:lnSpc>
+              <a:buFont typeface="Arial" panose="020B0604020202020204" pitchFamily="34" charset="0"/>
+              <a:buChar char="•"/>
+            </a:pPr>
+            <a:r>
+              <a:rPr lang="en-US"/>
+              <a:t>@import 'bootstrap-icons/font/bootstrap-icons.css’;</a:t>
+            </a:r>
+          </a:p>
+          <a:p>
+            <a:pPr>
+              <a:lnSpc>
+                <a:spcPct val="150000"/>
+              </a:lnSpc>
+              <a:buNone/>
+            </a:pPr>
+            <a:endParaRPr kumimoji="0" lang="az-Latn-AZ" altLang="en-US" sz="1300" b="0" i="0" u="none" strike="noStrike" cap="none" normalizeH="0" baseline="0">
+              <a:ln>
+                <a:noFill/>
+              </a:ln>
+              <a:solidFill>
+                <a:schemeClr val="tx1"/>
+              </a:solidFill>
+              <a:effectLst/>
+              <a:latin typeface="Arial" panose="020B0604020202020204" pitchFamily="34" charset="0"/>
+            </a:endParaRPr>
+          </a:p>
+          <a:p>
+            <a:pPr>
+              <a:lnSpc>
+                <a:spcPct val="150000"/>
+              </a:lnSpc>
+              <a:buNone/>
+            </a:pPr>
+            <a:r>
+              <a:rPr kumimoji="0" lang="az-Latn-AZ" altLang="en-US" sz="1300" b="0" i="0" u="none" strike="noStrike" cap="none" normalizeH="0" baseline="0">
                 <a:ln>
                   <a:noFill/>
                 </a:ln>
@@ -4021,11 +4492,67 @@
                 <a:effectLst/>
                 <a:latin typeface="Arial" panose="020B0604020202020204" pitchFamily="34" charset="0"/>
               </a:rPr>
-              <a:t>.</a:t>
+              <a:t>Ancaq hansı səbəbdəndir bilmirəm bu fayl avtomatik olaraq yaradılmamışdır. İstəsək əslində özümüzdə yarada bilərdik. Ancaq mən artıq </a:t>
+            </a:r>
+            <a:r>
+              <a:rPr kumimoji="0" lang="az-Latn-AZ" altLang="en-US" sz="1300" b="1" i="0" u="none" strike="noStrike" cap="none" normalizeH="0" baseline="0">
+                <a:ln>
+                  <a:noFill/>
+                </a:ln>
+                <a:solidFill>
+                  <a:schemeClr val="tx1"/>
+                </a:solidFill>
+                <a:effectLst/>
+                <a:latin typeface="Arial" panose="020B0604020202020204" pitchFamily="34" charset="0"/>
+              </a:rPr>
+              <a:t>CDN link </a:t>
+            </a:r>
+            <a:r>
+              <a:rPr kumimoji="0" lang="az-Latn-AZ" altLang="en-US" sz="1300" b="0" i="0" u="none" strike="noStrike" cap="none" normalizeH="0" baseline="0">
+                <a:ln>
+                  <a:noFill/>
+                </a:ln>
+                <a:solidFill>
+                  <a:schemeClr val="tx1"/>
+                </a:solidFill>
+                <a:effectLst/>
+                <a:latin typeface="Arial" panose="020B0604020202020204" pitchFamily="34" charset="0"/>
+              </a:rPr>
+              <a:t>istifadə etdim.</a:t>
             </a:r>
           </a:p>
         </p:txBody>
       </p:sp>
+      <p:pic>
+        <p:nvPicPr>
+          <p:cNvPr id="4" name="Picture 3">
+            <a:extLst>
+              <a:ext uri="{FF2B5EF4-FFF2-40B4-BE49-F238E27FC236}">
+                <a16:creationId xmlns:a16="http://schemas.microsoft.com/office/drawing/2014/main" id="{6A3FF671-CFCF-A506-8863-C06AC2FF9856}"/>
+              </a:ext>
+            </a:extLst>
+          </p:cNvPr>
+          <p:cNvPicPr>
+            <a:picLocks noChangeAspect="1"/>
+          </p:cNvPicPr>
+          <p:nvPr/>
+        </p:nvPicPr>
+        <p:blipFill>
+          <a:blip r:embed="rId2"/>
+          <a:stretch>
+            <a:fillRect/>
+          </a:stretch>
+        </p:blipFill>
+        <p:spPr>
+          <a:xfrm>
+            <a:off x="3326121" y="2703239"/>
+            <a:ext cx="4867954" cy="2981741"/>
+          </a:xfrm>
+          <a:prstGeom prst="rect">
+            <a:avLst/>
+          </a:prstGeom>
+        </p:spPr>
+      </p:pic>
     </p:spTree>
     <p:extLst>
       <p:ext uri="{BB962C8B-B14F-4D97-AF65-F5344CB8AC3E}">
@@ -4076,8 +4603,8 @@
         </p:nvSpPr>
         <p:spPr>
           <a:xfrm>
-            <a:off x="217714" y="255046"/>
-            <a:ext cx="11756571" cy="355354"/>
+            <a:off x="217715" y="141178"/>
+            <a:ext cx="11756571" cy="3956339"/>
           </a:xfrm>
           <a:prstGeom prst="rect">
             <a:avLst/>
@@ -4097,7 +4624,7 @@
               <a:buNone/>
             </a:pPr>
             <a:r>
-              <a:rPr kumimoji="0" lang="en-US" altLang="en-US" sz="1300" b="0" i="0" u="none" strike="noStrike" cap="none" normalizeH="0" baseline="0">
+              <a:rPr kumimoji="0" lang="az-Latn-AZ" altLang="en-US" sz="1300" b="0" i="0" u="none" strike="noStrike" cap="none" normalizeH="0" baseline="0">
                 <a:ln>
                   <a:noFill/>
                 </a:ln>
@@ -4107,11 +4634,417 @@
                 <a:effectLst/>
                 <a:latin typeface="Arial" panose="020B0604020202020204" pitchFamily="34" charset="0"/>
               </a:rPr>
-              <a:t>.</a:t>
-            </a:r>
+              <a:t>Bu ikonlardan məsələn birincisini kliklədikdə aşağıdakı kimi bir xəta </a:t>
+            </a:r>
+            <a:r>
+              <a:rPr lang="az-Latn-AZ" altLang="en-US" sz="1300">
+                <a:latin typeface="Arial" panose="020B0604020202020204" pitchFamily="34" charset="0"/>
+              </a:rPr>
+              <a:t>görəcəyik.</a:t>
+            </a:r>
+          </a:p>
+          <a:p>
+            <a:pPr>
+              <a:lnSpc>
+                <a:spcPct val="150000"/>
+              </a:lnSpc>
+              <a:buNone/>
+            </a:pPr>
+            <a:endParaRPr kumimoji="0" lang="az-Latn-AZ" altLang="en-US" sz="1300" b="0" i="0" u="none" strike="noStrike" cap="none" normalizeH="0" baseline="0">
+              <a:ln>
+                <a:noFill/>
+              </a:ln>
+              <a:solidFill>
+                <a:schemeClr val="tx1"/>
+              </a:solidFill>
+              <a:effectLst/>
+              <a:latin typeface="Arial" panose="020B0604020202020204" pitchFamily="34" charset="0"/>
+            </a:endParaRPr>
+          </a:p>
+          <a:p>
+            <a:pPr>
+              <a:lnSpc>
+                <a:spcPct val="150000"/>
+              </a:lnSpc>
+              <a:buNone/>
+            </a:pPr>
+            <a:endParaRPr lang="az-Latn-AZ" altLang="en-US" sz="1300">
+              <a:latin typeface="Arial" panose="020B0604020202020204" pitchFamily="34" charset="0"/>
+            </a:endParaRPr>
+          </a:p>
+          <a:p>
+            <a:pPr>
+              <a:lnSpc>
+                <a:spcPct val="150000"/>
+              </a:lnSpc>
+              <a:buNone/>
+            </a:pPr>
+            <a:endParaRPr kumimoji="0" lang="az-Latn-AZ" altLang="en-US" sz="1300" b="0" i="0" u="none" strike="noStrike" cap="none" normalizeH="0" baseline="0">
+              <a:ln>
+                <a:noFill/>
+              </a:ln>
+              <a:solidFill>
+                <a:schemeClr val="tx1"/>
+              </a:solidFill>
+              <a:effectLst/>
+              <a:latin typeface="Arial" panose="020B0604020202020204" pitchFamily="34" charset="0"/>
+            </a:endParaRPr>
+          </a:p>
+          <a:p>
+            <a:pPr>
+              <a:lnSpc>
+                <a:spcPct val="150000"/>
+              </a:lnSpc>
+              <a:buNone/>
+            </a:pPr>
+            <a:endParaRPr lang="az-Latn-AZ" altLang="en-US" sz="1300">
+              <a:latin typeface="Arial" panose="020B0604020202020204" pitchFamily="34" charset="0"/>
+            </a:endParaRPr>
+          </a:p>
+          <a:p>
+            <a:pPr>
+              <a:lnSpc>
+                <a:spcPct val="150000"/>
+              </a:lnSpc>
+              <a:buNone/>
+            </a:pPr>
+            <a:endParaRPr kumimoji="0" lang="az-Latn-AZ" altLang="en-US" sz="1300" b="0" i="0" u="none" strike="noStrike" cap="none" normalizeH="0" baseline="0">
+              <a:ln>
+                <a:noFill/>
+              </a:ln>
+              <a:solidFill>
+                <a:schemeClr val="tx1"/>
+              </a:solidFill>
+              <a:effectLst/>
+              <a:latin typeface="Arial" panose="020B0604020202020204" pitchFamily="34" charset="0"/>
+            </a:endParaRPr>
+          </a:p>
+          <a:p>
+            <a:pPr>
+              <a:lnSpc>
+                <a:spcPct val="150000"/>
+              </a:lnSpc>
+              <a:buNone/>
+            </a:pPr>
+            <a:endParaRPr lang="az-Latn-AZ" altLang="en-US" sz="1300">
+              <a:latin typeface="Arial" panose="020B0604020202020204" pitchFamily="34" charset="0"/>
+            </a:endParaRPr>
+          </a:p>
+          <a:p>
+            <a:pPr>
+              <a:lnSpc>
+                <a:spcPct val="150000"/>
+              </a:lnSpc>
+              <a:buNone/>
+            </a:pPr>
+            <a:endParaRPr kumimoji="0" lang="az-Latn-AZ" altLang="en-US" sz="1300" b="0" i="0" u="none" strike="noStrike" cap="none" normalizeH="0" baseline="0">
+              <a:ln>
+                <a:noFill/>
+              </a:ln>
+              <a:solidFill>
+                <a:schemeClr val="tx1"/>
+              </a:solidFill>
+              <a:effectLst/>
+              <a:latin typeface="Arial" panose="020B0604020202020204" pitchFamily="34" charset="0"/>
+            </a:endParaRPr>
+          </a:p>
+          <a:p>
+            <a:pPr>
+              <a:lnSpc>
+                <a:spcPct val="150000"/>
+              </a:lnSpc>
+              <a:buNone/>
+            </a:pPr>
+            <a:endParaRPr lang="az-Latn-AZ" altLang="en-US" sz="1300">
+              <a:latin typeface="Arial" panose="020B0604020202020204" pitchFamily="34" charset="0"/>
+            </a:endParaRPr>
+          </a:p>
+          <a:p>
+            <a:pPr>
+              <a:lnSpc>
+                <a:spcPct val="150000"/>
+              </a:lnSpc>
+              <a:buNone/>
+            </a:pPr>
+            <a:r>
+              <a:rPr kumimoji="0" lang="az-Latn-AZ" altLang="en-US" sz="1300" b="0" i="0" u="none" strike="noStrike" cap="none" normalizeH="0" baseline="0">
+                <a:ln>
+                  <a:noFill/>
+                </a:ln>
+                <a:solidFill>
+                  <a:schemeClr val="tx1"/>
+                </a:solidFill>
+                <a:effectLst/>
+                <a:latin typeface="Arial" panose="020B0604020202020204" pitchFamily="34" charset="0"/>
+              </a:rPr>
+              <a:t>Bu xəta onu bildiririk ki, </a:t>
+            </a:r>
+            <a:r>
+              <a:rPr kumimoji="0" lang="az-Latn-AZ" altLang="en-US" sz="1300" b="1" i="0" u="none" strike="noStrike" cap="none" normalizeH="0" baseline="0">
+                <a:ln>
+                  <a:noFill/>
+                </a:ln>
+                <a:solidFill>
+                  <a:schemeClr val="tx1"/>
+                </a:solidFill>
+                <a:effectLst/>
+                <a:latin typeface="Arial" panose="020B0604020202020204" pitchFamily="34" charset="0"/>
+              </a:rPr>
+              <a:t>dataları EXCEL formatında </a:t>
+            </a:r>
+            <a:r>
+              <a:rPr kumimoji="0" lang="az-Latn-AZ" altLang="en-US" sz="1300" b="0" i="0" u="none" strike="noStrike" cap="none" normalizeH="0" baseline="0">
+                <a:ln>
+                  <a:noFill/>
+                </a:ln>
+                <a:solidFill>
+                  <a:schemeClr val="tx1"/>
+                </a:solidFill>
+                <a:effectLst/>
+                <a:latin typeface="Arial" panose="020B0604020202020204" pitchFamily="34" charset="0"/>
+              </a:rPr>
+              <a:t>endirmək üçün gərəkli olan </a:t>
+            </a:r>
+            <a:r>
+              <a:rPr kumimoji="0" lang="az-Latn-AZ" altLang="en-US" sz="1300" b="1" i="0" u="none" strike="noStrike" cap="none" normalizeH="0" baseline="0">
+                <a:ln>
+                  <a:noFill/>
+                </a:ln>
+                <a:solidFill>
+                  <a:schemeClr val="tx1"/>
+                </a:solidFill>
+                <a:effectLst/>
+                <a:latin typeface="Arial" panose="020B0604020202020204" pitchFamily="34" charset="0"/>
+              </a:rPr>
+              <a:t>funksiya</a:t>
+            </a:r>
+            <a:r>
+              <a:rPr kumimoji="0" lang="az-Latn-AZ" altLang="en-US" sz="1300" b="0" i="0" u="none" strike="noStrike" cap="none" normalizeH="0" baseline="0">
+                <a:ln>
+                  <a:noFill/>
+                </a:ln>
+                <a:solidFill>
+                  <a:schemeClr val="tx1"/>
+                </a:solidFill>
+                <a:effectLst/>
+                <a:latin typeface="Arial" panose="020B0604020202020204" pitchFamily="34" charset="0"/>
+              </a:rPr>
+              <a:t> yoxdur və </a:t>
+            </a:r>
+            <a:r>
+              <a:rPr kumimoji="0" lang="az-Latn-AZ" altLang="en-US" sz="1300" b="1" i="0" u="none" strike="noStrike" cap="none" normalizeH="0" baseline="0">
+                <a:ln>
+                  <a:noFill/>
+                </a:ln>
+                <a:solidFill>
+                  <a:schemeClr val="tx1"/>
+                </a:solidFill>
+                <a:effectLst/>
+                <a:latin typeface="Arial" panose="020B0604020202020204" pitchFamily="34" charset="0"/>
+              </a:rPr>
+              <a:t>maat</a:t>
+            </a:r>
+            <a:r>
+              <a:rPr kumimoji="0" lang="en-US" altLang="en-US" sz="1300" b="1" i="0" u="none" strike="noStrike" cap="none" normalizeH="0" baseline="0">
+                <a:ln>
+                  <a:noFill/>
+                </a:ln>
+                <a:solidFill>
+                  <a:schemeClr val="tx1"/>
+                </a:solidFill>
+                <a:effectLst/>
+                <a:latin typeface="Arial" panose="020B0604020202020204" pitchFamily="34" charset="0"/>
+              </a:rPr>
+              <a:t>website/excel </a:t>
+            </a:r>
+            <a:r>
+              <a:rPr kumimoji="0" lang="az-Latn-AZ" altLang="en-US" sz="1300" b="0" i="0" u="none" strike="noStrike" cap="none" normalizeH="0" baseline="0">
+                <a:ln>
+                  <a:noFill/>
+                </a:ln>
+                <a:solidFill>
+                  <a:schemeClr val="tx1"/>
+                </a:solidFill>
+                <a:effectLst/>
+                <a:latin typeface="Arial" panose="020B0604020202020204" pitchFamily="34" charset="0"/>
+              </a:rPr>
+              <a:t>adlı </a:t>
+            </a:r>
+            <a:r>
+              <a:rPr kumimoji="0" lang="az-Latn-AZ" altLang="en-US" sz="1300" b="1" i="0" u="none" strike="noStrike" cap="none" normalizeH="0" baseline="0">
+                <a:ln>
+                  <a:noFill/>
+                </a:ln>
+                <a:solidFill>
+                  <a:schemeClr val="tx1"/>
+                </a:solidFill>
+                <a:effectLst/>
+                <a:latin typeface="Arial" panose="020B0604020202020204" pitchFamily="34" charset="0"/>
+              </a:rPr>
+              <a:t>paket</a:t>
+            </a:r>
+            <a:r>
+              <a:rPr kumimoji="0" lang="az-Latn-AZ" altLang="en-US" sz="1300" b="0" i="0" u="none" strike="noStrike" cap="none" normalizeH="0" baseline="0">
+                <a:ln>
+                  <a:noFill/>
+                </a:ln>
+                <a:solidFill>
+                  <a:schemeClr val="tx1"/>
+                </a:solidFill>
+                <a:effectLst/>
+                <a:latin typeface="Arial" panose="020B0604020202020204" pitchFamily="34" charset="0"/>
+              </a:rPr>
+              <a:t> endirin. </a:t>
+            </a:r>
+          </a:p>
+          <a:p>
+            <a:pPr>
+              <a:lnSpc>
+                <a:spcPct val="150000"/>
+              </a:lnSpc>
+              <a:buNone/>
+            </a:pPr>
+            <a:r>
+              <a:rPr lang="en-US" altLang="en-US" sz="1300" u="sng">
+                <a:solidFill>
+                  <a:srgbClr val="00B0F0"/>
+                </a:solidFill>
+                <a:latin typeface="Arial" panose="020B0604020202020204" pitchFamily="34" charset="0"/>
+              </a:rPr>
+              <a:t>https://docs.laravel-excel.com/3.1/getting-started/installation.html</a:t>
+            </a:r>
+            <a:endParaRPr lang="az-Latn-AZ" altLang="en-US" sz="1300" u="sng">
+              <a:solidFill>
+                <a:srgbClr val="00B0F0"/>
+              </a:solidFill>
+              <a:latin typeface="Arial" panose="020B0604020202020204" pitchFamily="34" charset="0"/>
+            </a:endParaRPr>
+          </a:p>
+          <a:p>
+            <a:pPr>
+              <a:lnSpc>
+                <a:spcPct val="150000"/>
+              </a:lnSpc>
+              <a:buNone/>
+            </a:pPr>
+            <a:endParaRPr kumimoji="0" lang="az-Latn-AZ" altLang="en-US" sz="1300" b="0" i="0" u="none" strike="noStrike" cap="none" normalizeH="0" baseline="0">
+              <a:ln>
+                <a:noFill/>
+              </a:ln>
+              <a:solidFill>
+                <a:schemeClr val="tx1"/>
+              </a:solidFill>
+              <a:effectLst/>
+              <a:latin typeface="Arial" panose="020B0604020202020204" pitchFamily="34" charset="0"/>
+            </a:endParaRPr>
+          </a:p>
+          <a:p>
+            <a:pPr>
+              <a:lnSpc>
+                <a:spcPct val="150000"/>
+              </a:lnSpc>
+              <a:buNone/>
+            </a:pPr>
+            <a:r>
+              <a:rPr kumimoji="0" lang="az-Latn-AZ" altLang="en-US" sz="1300" b="0" i="0" u="none" strike="noStrike" cap="none" normalizeH="0" baseline="0">
+                <a:ln>
+                  <a:noFill/>
+                </a:ln>
+                <a:solidFill>
+                  <a:schemeClr val="tx1"/>
+                </a:solidFill>
+                <a:effectLst/>
+                <a:latin typeface="Arial" panose="020B0604020202020204" pitchFamily="34" charset="0"/>
+              </a:rPr>
+              <a:t>Paketin quraşdırma addımları saytda qeyd edilmişdir.... Növbəti slayd.....</a:t>
+            </a:r>
+            <a:endParaRPr kumimoji="0" lang="en-US" altLang="en-US" sz="1300" b="0" i="0" u="none" strike="noStrike" cap="none" normalizeH="0" baseline="0">
+              <a:ln>
+                <a:noFill/>
+              </a:ln>
+              <a:solidFill>
+                <a:schemeClr val="tx1"/>
+              </a:solidFill>
+              <a:effectLst/>
+              <a:latin typeface="Arial" panose="020B0604020202020204" pitchFamily="34" charset="0"/>
+            </a:endParaRPr>
           </a:p>
         </p:txBody>
       </p:sp>
+      <p:pic>
+        <p:nvPicPr>
+          <p:cNvPr id="4" name="Picture 3">
+            <a:extLst>
+              <a:ext uri="{FF2B5EF4-FFF2-40B4-BE49-F238E27FC236}">
+                <a16:creationId xmlns:a16="http://schemas.microsoft.com/office/drawing/2014/main" id="{688C5F49-04AF-3276-1977-A0A7E6E6CD5F}"/>
+              </a:ext>
+            </a:extLst>
+          </p:cNvPr>
+          <p:cNvPicPr>
+            <a:picLocks noChangeAspect="1"/>
+          </p:cNvPicPr>
+          <p:nvPr/>
+        </p:nvPicPr>
+        <p:blipFill>
+          <a:blip r:embed="rId2"/>
+          <a:stretch>
+            <a:fillRect/>
+          </a:stretch>
+        </p:blipFill>
+        <p:spPr>
+          <a:xfrm>
+            <a:off x="217714" y="650240"/>
+            <a:ext cx="3934374" cy="1190791"/>
+          </a:xfrm>
+          <a:prstGeom prst="rect">
+            <a:avLst/>
+          </a:prstGeom>
+          <a:ln w="38100" cap="sq">
+            <a:solidFill>
+              <a:srgbClr val="000000"/>
+            </a:solidFill>
+            <a:prstDash val="solid"/>
+            <a:miter lim="800000"/>
+          </a:ln>
+          <a:effectLst>
+            <a:outerShdw blurRad="50800" dist="38100" dir="2700000" algn="tl" rotWithShape="0">
+              <a:srgbClr val="000000">
+                <a:alpha val="43000"/>
+              </a:srgbClr>
+            </a:outerShdw>
+          </a:effectLst>
+        </p:spPr>
+      </p:pic>
+      <p:pic>
+        <p:nvPicPr>
+          <p:cNvPr id="6" name="Picture 5">
+            <a:extLst>
+              <a:ext uri="{FF2B5EF4-FFF2-40B4-BE49-F238E27FC236}">
+                <a16:creationId xmlns:a16="http://schemas.microsoft.com/office/drawing/2014/main" id="{9D260B37-6AA5-32DD-C566-2375D7265C78}"/>
+              </a:ext>
+            </a:extLst>
+          </p:cNvPr>
+          <p:cNvPicPr>
+            <a:picLocks noChangeAspect="1"/>
+          </p:cNvPicPr>
+          <p:nvPr/>
+        </p:nvPicPr>
+        <p:blipFill>
+          <a:blip r:embed="rId3"/>
+          <a:stretch>
+            <a:fillRect/>
+          </a:stretch>
+        </p:blipFill>
+        <p:spPr>
+          <a:xfrm>
+            <a:off x="217714" y="4200154"/>
+            <a:ext cx="8478433" cy="2657846"/>
+          </a:xfrm>
+          <a:prstGeom prst="rect">
+            <a:avLst/>
+          </a:prstGeom>
+        </p:spPr>
+      </p:pic>
     </p:spTree>
     <p:extLst>
       <p:ext uri="{BB962C8B-B14F-4D97-AF65-F5344CB8AC3E}">
@@ -4133,7 +5066,7 @@
         <p:cNvPr id="1" name="">
           <a:extLst>
             <a:ext uri="{FF2B5EF4-FFF2-40B4-BE49-F238E27FC236}">
-              <a16:creationId xmlns:a16="http://schemas.microsoft.com/office/drawing/2014/main" id="{7FF4C2B8-6ABD-298A-A51C-0A09C2AC80F9}"/>
+              <a16:creationId xmlns:a16="http://schemas.microsoft.com/office/drawing/2014/main" id="{74E2CAA1-291E-2C57-F7D9-DF7EF45CBA19}"/>
             </a:ext>
           </a:extLst>
         </p:cNvPr>
@@ -4153,7 +5086,7 @@
           <p:cNvPr id="3" name="TextBox 2">
             <a:extLst>
               <a:ext uri="{FF2B5EF4-FFF2-40B4-BE49-F238E27FC236}">
-                <a16:creationId xmlns:a16="http://schemas.microsoft.com/office/drawing/2014/main" id="{DEE0DC95-9EDC-608A-D71C-0906D5D52A6E}"/>
+                <a16:creationId xmlns:a16="http://schemas.microsoft.com/office/drawing/2014/main" id="{FAEC0879-2FAD-C2BD-BE7F-06A2D6FEBF58}"/>
               </a:ext>
             </a:extLst>
           </p:cNvPr>
@@ -4198,10 +5131,54 @@
           </a:p>
         </p:txBody>
       </p:sp>
+      <p:pic>
+        <p:nvPicPr>
+          <p:cNvPr id="4" name="Picture 3">
+            <a:extLst>
+              <a:ext uri="{FF2B5EF4-FFF2-40B4-BE49-F238E27FC236}">
+                <a16:creationId xmlns:a16="http://schemas.microsoft.com/office/drawing/2014/main" id="{8E6BC9B2-D523-DE9C-5DB8-6438630D1CEE}"/>
+              </a:ext>
+            </a:extLst>
+          </p:cNvPr>
+          <p:cNvPicPr>
+            <a:picLocks noChangeAspect="1"/>
+          </p:cNvPicPr>
+          <p:nvPr/>
+        </p:nvPicPr>
+        <p:blipFill>
+          <a:blip r:embed="rId2"/>
+          <a:stretch>
+            <a:fillRect/>
+          </a:stretch>
+        </p:blipFill>
+        <p:spPr>
+          <a:xfrm>
+            <a:off x="1313781" y="480601"/>
+            <a:ext cx="9564435" cy="5896798"/>
+          </a:xfrm>
+          <a:prstGeom prst="rect">
+            <a:avLst/>
+          </a:prstGeom>
+          <a:ln w="38100" cap="sq">
+            <a:solidFill>
+              <a:srgbClr val="000000"/>
+            </a:solidFill>
+            <a:prstDash val="solid"/>
+            <a:miter lim="800000"/>
+          </a:ln>
+          <a:effectLst>
+            <a:outerShdw blurRad="50800" dist="38100" dir="2700000" algn="tl" rotWithShape="0">
+              <a:srgbClr val="000000">
+                <a:alpha val="43000"/>
+              </a:srgbClr>
+            </a:outerShdw>
+          </a:effectLst>
+        </p:spPr>
+      </p:pic>
     </p:spTree>
     <p:extLst>
       <p:ext uri="{BB962C8B-B14F-4D97-AF65-F5344CB8AC3E}">
-        <p14:creationId xmlns:p14="http://schemas.microsoft.com/office/powerpoint/2010/main" val="1406546416"/>
+        <p14:creationId xmlns:p14="http://schemas.microsoft.com/office/powerpoint/2010/main" val="4143467304"/>
       </p:ext>
     </p:extLst>
   </p:cSld>
@@ -4219,7 +5196,7 @@
         <p:cNvPr id="1" name="">
           <a:extLst>
             <a:ext uri="{FF2B5EF4-FFF2-40B4-BE49-F238E27FC236}">
-              <a16:creationId xmlns:a16="http://schemas.microsoft.com/office/drawing/2014/main" id="{A2506587-490C-7C61-1F61-C2106CCEB092}"/>
+              <a16:creationId xmlns:a16="http://schemas.microsoft.com/office/drawing/2014/main" id="{1B13FD7D-3B43-E570-B125-873C5FB04FFE}"/>
             </a:ext>
           </a:extLst>
         </p:cNvPr>
@@ -4239,7 +5216,536 @@
           <p:cNvPr id="3" name="TextBox 2">
             <a:extLst>
               <a:ext uri="{FF2B5EF4-FFF2-40B4-BE49-F238E27FC236}">
-                <a16:creationId xmlns:a16="http://schemas.microsoft.com/office/drawing/2014/main" id="{6B8412FD-760B-2AE4-4872-A59438CF723F}"/>
+                <a16:creationId xmlns:a16="http://schemas.microsoft.com/office/drawing/2014/main" id="{40A0C6E7-2D53-00F9-1641-28EDA46E4188}"/>
+              </a:ext>
+            </a:extLst>
+          </p:cNvPr>
+          <p:cNvSpPr txBox="1"/>
+          <p:nvPr/>
+        </p:nvSpPr>
+        <p:spPr>
+          <a:xfrm>
+            <a:off x="217714" y="255046"/>
+            <a:ext cx="11756571" cy="6056915"/>
+          </a:xfrm>
+          <a:prstGeom prst="rect">
+            <a:avLst/>
+          </a:prstGeom>
+          <a:noFill/>
+        </p:spPr>
+        <p:txBody>
+          <a:bodyPr wrap="square">
+            <a:spAutoFit/>
+          </a:bodyPr>
+          <a:lstStyle/>
+          <a:p>
+            <a:pPr>
+              <a:lnSpc>
+                <a:spcPct val="150000"/>
+              </a:lnSpc>
+              <a:buNone/>
+            </a:pPr>
+            <a:r>
+              <a:rPr lang="az-Latn-AZ" altLang="en-US" sz="1300">
+                <a:latin typeface="Arial" panose="020B0604020202020204" pitchFamily="34" charset="0"/>
+              </a:rPr>
+              <a:t>Sonra isə, </a:t>
+            </a:r>
+            <a:r>
+              <a:rPr lang="en-US" altLang="en-US" sz="1300" b="1">
+                <a:latin typeface="Arial" panose="020B0604020202020204" pitchFamily="34" charset="0"/>
+              </a:rPr>
+              <a:t>Maatwebsite Excel </a:t>
+            </a:r>
+            <a:r>
+              <a:rPr lang="en-US" altLang="en-US" sz="1300">
+                <a:latin typeface="Arial" panose="020B0604020202020204" pitchFamily="34" charset="0"/>
+              </a:rPr>
+              <a:t>paketinin konfiqurasiya faylını layihənin </a:t>
+            </a:r>
+            <a:r>
+              <a:rPr lang="en-US" altLang="en-US" sz="1300" b="1">
+                <a:latin typeface="Arial" panose="020B0604020202020204" pitchFamily="34" charset="0"/>
+              </a:rPr>
+              <a:t>config</a:t>
+            </a:r>
+            <a:r>
+              <a:rPr lang="en-US" altLang="en-US" sz="1300">
+                <a:latin typeface="Arial" panose="020B0604020202020204" pitchFamily="34" charset="0"/>
+              </a:rPr>
+              <a:t> qovluğuna çıxarmaq (publish etmək) üçün</a:t>
+            </a:r>
+            <a:r>
+              <a:rPr lang="az-Latn-AZ" altLang="en-US" sz="1300">
+                <a:latin typeface="Arial" panose="020B0604020202020204" pitchFamily="34" charset="0"/>
+              </a:rPr>
+              <a:t> aşağıdakı əmri yazırıq: </a:t>
+            </a:r>
+          </a:p>
+          <a:p>
+            <a:pPr>
+              <a:lnSpc>
+                <a:spcPct val="150000"/>
+              </a:lnSpc>
+              <a:buNone/>
+            </a:pPr>
+            <a:endParaRPr kumimoji="0" lang="az-Latn-AZ" altLang="en-US" sz="1300" b="0" i="0" u="none" strike="noStrike" cap="none" normalizeH="0" baseline="0">
+              <a:ln>
+                <a:noFill/>
+              </a:ln>
+              <a:solidFill>
+                <a:schemeClr val="tx1"/>
+              </a:solidFill>
+              <a:effectLst/>
+              <a:latin typeface="Arial" panose="020B0604020202020204" pitchFamily="34" charset="0"/>
+            </a:endParaRPr>
+          </a:p>
+          <a:p>
+            <a:pPr>
+              <a:lnSpc>
+                <a:spcPct val="150000"/>
+              </a:lnSpc>
+              <a:buNone/>
+            </a:pPr>
+            <a:endParaRPr lang="az-Latn-AZ" altLang="en-US" sz="1300">
+              <a:latin typeface="Arial" panose="020B0604020202020204" pitchFamily="34" charset="0"/>
+            </a:endParaRPr>
+          </a:p>
+          <a:p>
+            <a:pPr>
+              <a:lnSpc>
+                <a:spcPct val="150000"/>
+              </a:lnSpc>
+              <a:buNone/>
+            </a:pPr>
+            <a:endParaRPr kumimoji="0" lang="az-Latn-AZ" altLang="en-US" sz="1300" b="0" i="0" u="none" strike="noStrike" cap="none" normalizeH="0" baseline="0">
+              <a:ln>
+                <a:noFill/>
+              </a:ln>
+              <a:solidFill>
+                <a:schemeClr val="tx1"/>
+              </a:solidFill>
+              <a:effectLst/>
+              <a:latin typeface="Arial" panose="020B0604020202020204" pitchFamily="34" charset="0"/>
+            </a:endParaRPr>
+          </a:p>
+          <a:p>
+            <a:pPr>
+              <a:lnSpc>
+                <a:spcPct val="150000"/>
+              </a:lnSpc>
+              <a:buNone/>
+            </a:pPr>
+            <a:endParaRPr lang="az-Latn-AZ" altLang="en-US" sz="1300">
+              <a:latin typeface="Arial" panose="020B0604020202020204" pitchFamily="34" charset="0"/>
+            </a:endParaRPr>
+          </a:p>
+          <a:p>
+            <a:pPr>
+              <a:lnSpc>
+                <a:spcPct val="150000"/>
+              </a:lnSpc>
+              <a:buNone/>
+            </a:pPr>
+            <a:endParaRPr kumimoji="0" lang="az-Latn-AZ" altLang="en-US" sz="1300" b="0" i="0" u="none" strike="noStrike" cap="none" normalizeH="0" baseline="0">
+              <a:ln>
+                <a:noFill/>
+              </a:ln>
+              <a:solidFill>
+                <a:schemeClr val="tx1"/>
+              </a:solidFill>
+              <a:effectLst/>
+              <a:latin typeface="Arial" panose="020B0604020202020204" pitchFamily="34" charset="0"/>
+            </a:endParaRPr>
+          </a:p>
+          <a:p>
+            <a:pPr>
+              <a:lnSpc>
+                <a:spcPct val="150000"/>
+              </a:lnSpc>
+              <a:buNone/>
+            </a:pPr>
+            <a:endParaRPr lang="az-Latn-AZ" altLang="en-US" sz="1300">
+              <a:latin typeface="Arial" panose="020B0604020202020204" pitchFamily="34" charset="0"/>
+            </a:endParaRPr>
+          </a:p>
+          <a:p>
+            <a:pPr>
+              <a:lnSpc>
+                <a:spcPct val="150000"/>
+              </a:lnSpc>
+              <a:buNone/>
+            </a:pPr>
+            <a:endParaRPr kumimoji="0" lang="az-Latn-AZ" altLang="en-US" sz="1300" b="0" i="0" u="none" strike="noStrike" cap="none" normalizeH="0" baseline="0">
+              <a:ln>
+                <a:noFill/>
+              </a:ln>
+              <a:solidFill>
+                <a:schemeClr val="tx1"/>
+              </a:solidFill>
+              <a:effectLst/>
+              <a:latin typeface="Arial" panose="020B0604020202020204" pitchFamily="34" charset="0"/>
+            </a:endParaRPr>
+          </a:p>
+          <a:p>
+            <a:pPr>
+              <a:lnSpc>
+                <a:spcPct val="150000"/>
+              </a:lnSpc>
+              <a:buNone/>
+            </a:pPr>
+            <a:r>
+              <a:rPr lang="en-US" altLang="en-US" sz="1300">
+                <a:latin typeface="Arial" panose="020B0604020202020204" pitchFamily="34" charset="0"/>
+              </a:rPr>
+              <a:t>Bu əmr nəticəsində `</a:t>
+            </a:r>
+            <a:r>
+              <a:rPr lang="en-US" altLang="en-US" sz="1300" b="1">
+                <a:latin typeface="Arial" panose="020B0604020202020204" pitchFamily="34" charset="0"/>
+              </a:rPr>
+              <a:t>config/excel.php</a:t>
+            </a:r>
+            <a:r>
+              <a:rPr lang="en-US" altLang="en-US" sz="1300">
+                <a:latin typeface="Arial" panose="020B0604020202020204" pitchFamily="34" charset="0"/>
+              </a:rPr>
+              <a:t>` </a:t>
+            </a:r>
+            <a:r>
+              <a:rPr lang="az-Latn-AZ" altLang="en-US" sz="1300">
+                <a:latin typeface="Arial" panose="020B0604020202020204" pitchFamily="34" charset="0"/>
+              </a:rPr>
+              <a:t>adında</a:t>
+            </a:r>
+            <a:r>
+              <a:rPr lang="en-US" altLang="en-US" sz="1300">
+                <a:latin typeface="Arial" panose="020B0604020202020204" pitchFamily="34" charset="0"/>
+              </a:rPr>
+              <a:t> fayl yaranır</a:t>
+            </a:r>
+            <a:r>
+              <a:rPr lang="az-Latn-AZ" altLang="en-US" sz="1300">
+                <a:latin typeface="Arial" panose="020B0604020202020204" pitchFamily="34" charset="0"/>
+              </a:rPr>
+              <a:t>.</a:t>
+            </a:r>
+            <a:r>
+              <a:rPr lang="en-US" altLang="en-US" sz="1300">
+                <a:latin typeface="Arial" panose="020B0604020202020204" pitchFamily="34" charset="0"/>
+              </a:rPr>
+              <a:t> Bu fayl vasitəsilə</a:t>
+            </a:r>
+            <a:r>
+              <a:rPr lang="az-Latn-AZ" altLang="en-US" sz="1300">
+                <a:latin typeface="Arial" panose="020B0604020202020204" pitchFamily="34" charset="0"/>
+              </a:rPr>
+              <a:t>,</a:t>
+            </a:r>
+            <a:r>
+              <a:rPr lang="en-US" altLang="en-US" sz="1300">
+                <a:latin typeface="Arial" panose="020B0604020202020204" pitchFamily="34" charset="0"/>
+              </a:rPr>
+              <a:t> </a:t>
+            </a:r>
+            <a:r>
+              <a:rPr lang="en-US" altLang="en-US" sz="1300" b="1">
+                <a:latin typeface="Arial" panose="020B0604020202020204" pitchFamily="34" charset="0"/>
+              </a:rPr>
+              <a:t>Maatwebsite Excel </a:t>
+            </a:r>
+            <a:r>
+              <a:rPr lang="en-US" altLang="en-US" sz="1300">
+                <a:latin typeface="Arial" panose="020B0604020202020204" pitchFamily="34" charset="0"/>
+              </a:rPr>
+              <a:t>paketinin bütün konfiqurasiya </a:t>
+            </a:r>
+            <a:r>
+              <a:rPr lang="az-Latn-AZ" altLang="en-US" sz="1300">
+                <a:latin typeface="Arial" panose="020B0604020202020204" pitchFamily="34" charset="0"/>
+              </a:rPr>
+              <a:t>parametrlərini</a:t>
+            </a:r>
+            <a:r>
+              <a:rPr lang="en-US" altLang="en-US" sz="1300">
+                <a:latin typeface="Arial" panose="020B0604020202020204" pitchFamily="34" charset="0"/>
+              </a:rPr>
+              <a:t> öz layihə</a:t>
+            </a:r>
+            <a:r>
+              <a:rPr lang="az-Latn-AZ" altLang="en-US" sz="1300">
+                <a:latin typeface="Arial" panose="020B0604020202020204" pitchFamily="34" charset="0"/>
+              </a:rPr>
+              <a:t>mizə</a:t>
+            </a:r>
+            <a:r>
+              <a:rPr lang="en-US" altLang="en-US" sz="1300">
+                <a:latin typeface="Arial" panose="020B0604020202020204" pitchFamily="34" charset="0"/>
+              </a:rPr>
+              <a:t> uyğun olaraq dəyişə bilər</a:t>
+            </a:r>
+            <a:r>
+              <a:rPr lang="az-Latn-AZ" altLang="en-US" sz="1300">
+                <a:latin typeface="Arial" panose="020B0604020202020204" pitchFamily="34" charset="0"/>
+              </a:rPr>
+              <a:t>ik.</a:t>
+            </a:r>
+            <a:endParaRPr lang="en-US" altLang="en-US" sz="1300">
+              <a:latin typeface="Arial" panose="020B0604020202020204" pitchFamily="34" charset="0"/>
+            </a:endParaRPr>
+          </a:p>
+          <a:p>
+            <a:pPr>
+              <a:lnSpc>
+                <a:spcPct val="150000"/>
+              </a:lnSpc>
+              <a:buNone/>
+            </a:pPr>
+            <a:endParaRPr kumimoji="0" lang="en-US" altLang="en-US" sz="1300" b="0" i="0" u="none" strike="noStrike" cap="none" normalizeH="0" baseline="0">
+              <a:ln>
+                <a:noFill/>
+              </a:ln>
+              <a:solidFill>
+                <a:schemeClr val="tx1"/>
+              </a:solidFill>
+              <a:effectLst/>
+              <a:latin typeface="Arial" panose="020B0604020202020204" pitchFamily="34" charset="0"/>
+            </a:endParaRPr>
+          </a:p>
+          <a:p>
+            <a:pPr>
+              <a:lnSpc>
+                <a:spcPct val="150000"/>
+              </a:lnSpc>
+              <a:buNone/>
+            </a:pPr>
+            <a:r>
+              <a:rPr lang="en-US" altLang="en-US" sz="1300" b="1">
+                <a:latin typeface="Arial" panose="020B0604020202020204" pitchFamily="34" charset="0"/>
+              </a:rPr>
+              <a:t>Nəyə yarayır?</a:t>
+            </a:r>
+          </a:p>
+          <a:p>
+            <a:pPr marL="742950" lvl="1" indent="-285750">
+              <a:lnSpc>
+                <a:spcPct val="150000"/>
+              </a:lnSpc>
+              <a:buFont typeface="Arial" panose="020B0604020202020204" pitchFamily="34" charset="0"/>
+              <a:buChar char="•"/>
+            </a:pPr>
+            <a:r>
+              <a:rPr lang="en-US" altLang="en-US" sz="1300" b="1">
+                <a:latin typeface="Arial" panose="020B0604020202020204" pitchFamily="34" charset="0"/>
+              </a:rPr>
+              <a:t>config/excel.php </a:t>
+            </a:r>
+            <a:r>
+              <a:rPr lang="en-US" altLang="en-US" sz="1300">
+                <a:latin typeface="Arial" panose="020B0604020202020204" pitchFamily="34" charset="0"/>
+              </a:rPr>
+              <a:t>sənə bu parametrləri dəyişmək imkanı verir:</a:t>
+            </a:r>
+          </a:p>
+          <a:p>
+            <a:pPr marL="742950" lvl="1" indent="-285750">
+              <a:lnSpc>
+                <a:spcPct val="150000"/>
+              </a:lnSpc>
+              <a:buFont typeface="Arial" panose="020B0604020202020204" pitchFamily="34" charset="0"/>
+              <a:buChar char="•"/>
+            </a:pPr>
+            <a:r>
+              <a:rPr lang="en-US" altLang="en-US" sz="1300">
+                <a:latin typeface="Arial" panose="020B0604020202020204" pitchFamily="34" charset="0"/>
+              </a:rPr>
+              <a:t>Default exporter və importer class-ları</a:t>
+            </a:r>
+          </a:p>
+          <a:p>
+            <a:pPr marL="742950" lvl="1" indent="-285750">
+              <a:lnSpc>
+                <a:spcPct val="150000"/>
+              </a:lnSpc>
+              <a:buFont typeface="Arial" panose="020B0604020202020204" pitchFamily="34" charset="0"/>
+              <a:buChar char="•"/>
+            </a:pPr>
+            <a:r>
+              <a:rPr lang="en-US" altLang="en-US" sz="1300">
+                <a:latin typeface="Arial" panose="020B0604020202020204" pitchFamily="34" charset="0"/>
+              </a:rPr>
+              <a:t>Chunk size (böyük faylları hissə-hissə oxumaq üçün)</a:t>
+            </a:r>
+          </a:p>
+          <a:p>
+            <a:pPr marL="742950" lvl="1" indent="-285750">
+              <a:lnSpc>
+                <a:spcPct val="150000"/>
+              </a:lnSpc>
+              <a:buFont typeface="Arial" panose="020B0604020202020204" pitchFamily="34" charset="0"/>
+              <a:buChar char="•"/>
+            </a:pPr>
+            <a:r>
+              <a:rPr lang="en-US" altLang="en-US" sz="1300">
+                <a:latin typeface="Arial" panose="020B0604020202020204" pitchFamily="34" charset="0"/>
+              </a:rPr>
+              <a:t>Caching sistemləri</a:t>
+            </a:r>
+          </a:p>
+          <a:p>
+            <a:pPr marL="742950" lvl="1" indent="-285750">
+              <a:lnSpc>
+                <a:spcPct val="150000"/>
+              </a:lnSpc>
+              <a:buFont typeface="Arial" panose="020B0604020202020204" pitchFamily="34" charset="0"/>
+              <a:buChar char="•"/>
+            </a:pPr>
+            <a:r>
+              <a:rPr lang="en-US" altLang="en-US" sz="1300">
+                <a:latin typeface="Arial" panose="020B0604020202020204" pitchFamily="34" charset="0"/>
+              </a:rPr>
+              <a:t>Temporary folder yolları</a:t>
+            </a:r>
+          </a:p>
+          <a:p>
+            <a:pPr marL="742950" lvl="1" indent="-285750">
+              <a:lnSpc>
+                <a:spcPct val="150000"/>
+              </a:lnSpc>
+              <a:buFont typeface="Arial" panose="020B0604020202020204" pitchFamily="34" charset="0"/>
+              <a:buChar char="•"/>
+            </a:pPr>
+            <a:r>
+              <a:rPr lang="en-US" altLang="en-US" sz="1300">
+                <a:latin typeface="Arial" panose="020B0604020202020204" pitchFamily="34" charset="0"/>
+              </a:rPr>
+              <a:t>CSV, XLSX, XLS formalarının özəl ayarları (encoding, delimiter və s.)</a:t>
+            </a:r>
+          </a:p>
+          <a:p>
+            <a:pPr>
+              <a:lnSpc>
+                <a:spcPct val="150000"/>
+              </a:lnSpc>
+              <a:buNone/>
+            </a:pPr>
+            <a:endParaRPr kumimoji="0" lang="en-US" altLang="en-US" sz="1300" b="0" i="0" u="none" strike="noStrike" cap="none" normalizeH="0" baseline="0">
+              <a:ln>
+                <a:noFill/>
+              </a:ln>
+              <a:solidFill>
+                <a:schemeClr val="tx1"/>
+              </a:solidFill>
+              <a:effectLst/>
+              <a:latin typeface="Arial" panose="020B0604020202020204" pitchFamily="34" charset="0"/>
+            </a:endParaRPr>
+          </a:p>
+          <a:p>
+            <a:pPr>
+              <a:lnSpc>
+                <a:spcPct val="150000"/>
+              </a:lnSpc>
+              <a:buNone/>
+            </a:pPr>
+            <a:endParaRPr kumimoji="0" lang="en-US" altLang="en-US" sz="1300" b="0" i="0" u="none" strike="noStrike" cap="none" normalizeH="0" baseline="0">
+              <a:ln>
+                <a:noFill/>
+              </a:ln>
+              <a:solidFill>
+                <a:schemeClr val="tx1"/>
+              </a:solidFill>
+              <a:effectLst/>
+              <a:latin typeface="Arial" panose="020B0604020202020204" pitchFamily="34" charset="0"/>
+            </a:endParaRPr>
+          </a:p>
+        </p:txBody>
+      </p:sp>
+      <p:pic>
+        <p:nvPicPr>
+          <p:cNvPr id="5" name="Picture 4">
+            <a:extLst>
+              <a:ext uri="{FF2B5EF4-FFF2-40B4-BE49-F238E27FC236}">
+                <a16:creationId xmlns:a16="http://schemas.microsoft.com/office/drawing/2014/main" id="{E842C477-FB84-C602-B993-83EE6A40CAA7}"/>
+              </a:ext>
+            </a:extLst>
+          </p:cNvPr>
+          <p:cNvPicPr>
+            <a:picLocks noChangeAspect="1"/>
+          </p:cNvPicPr>
+          <p:nvPr/>
+        </p:nvPicPr>
+        <p:blipFill>
+          <a:blip r:embed="rId2"/>
+          <a:stretch>
+            <a:fillRect/>
+          </a:stretch>
+        </p:blipFill>
+        <p:spPr>
+          <a:xfrm>
+            <a:off x="217714" y="864715"/>
+            <a:ext cx="9535856" cy="1657581"/>
+          </a:xfrm>
+          <a:prstGeom prst="rect">
+            <a:avLst/>
+          </a:prstGeom>
+          <a:ln w="38100" cap="sq">
+            <a:solidFill>
+              <a:srgbClr val="000000"/>
+            </a:solidFill>
+            <a:prstDash val="solid"/>
+            <a:miter lim="800000"/>
+          </a:ln>
+          <a:effectLst>
+            <a:outerShdw blurRad="50800" dist="38100" dir="2700000" algn="tl" rotWithShape="0">
+              <a:srgbClr val="000000">
+                <a:alpha val="43000"/>
+              </a:srgbClr>
+            </a:outerShdw>
+          </a:effectLst>
+        </p:spPr>
+      </p:pic>
+    </p:spTree>
+    <p:extLst>
+      <p:ext uri="{BB962C8B-B14F-4D97-AF65-F5344CB8AC3E}">
+        <p14:creationId xmlns:p14="http://schemas.microsoft.com/office/powerpoint/2010/main" val="2588053517"/>
+      </p:ext>
+    </p:extLst>
+  </p:cSld>
+  <p:clrMapOvr>
+    <a:masterClrMapping/>
+  </p:clrMapOvr>
+</p:sld>
+</file>
+
+<file path=ppt/slides/slide19.xml><?xml version="1.0" encoding="utf-8"?>
+<p:sld xmlns:a="http://schemas.openxmlformats.org/drawingml/2006/main" xmlns:r="http://schemas.openxmlformats.org/officeDocument/2006/relationships" xmlns:p="http://schemas.openxmlformats.org/presentationml/2006/main">
+  <p:cSld>
+    <p:spTree>
+      <p:nvGrpSpPr>
+        <p:cNvPr id="1" name="">
+          <a:extLst>
+            <a:ext uri="{FF2B5EF4-FFF2-40B4-BE49-F238E27FC236}">
+              <a16:creationId xmlns:a16="http://schemas.microsoft.com/office/drawing/2014/main" id="{465EC222-3C9A-9B46-3042-C0EFEE45836F}"/>
+            </a:ext>
+          </a:extLst>
+        </p:cNvPr>
+        <p:cNvGrpSpPr/>
+        <p:nvPr/>
+      </p:nvGrpSpPr>
+      <p:grpSpPr>
+        <a:xfrm>
+          <a:off x="0" y="0"/>
+          <a:ext cx="0" cy="0"/>
+          <a:chOff x="0" y="0"/>
+          <a:chExt cx="0" cy="0"/>
+        </a:xfrm>
+      </p:grpSpPr>
+      <p:sp>
+        <p:nvSpPr>
+          <p:cNvPr id="3" name="TextBox 2">
+            <a:extLst>
+              <a:ext uri="{FF2B5EF4-FFF2-40B4-BE49-F238E27FC236}">
+                <a16:creationId xmlns:a16="http://schemas.microsoft.com/office/drawing/2014/main" id="{AC517089-B44A-1D7B-E131-23687AB1B34F}"/>
               </a:ext>
             </a:extLst>
           </p:cNvPr>
@@ -4269,25 +5775,90 @@
               <a:buNone/>
             </a:pPr>
             <a:r>
-              <a:rPr kumimoji="0" lang="en-US" altLang="en-US" sz="1300" b="0" i="0" u="none" strike="noStrike" cap="none" normalizeH="0" baseline="0">
-                <a:ln>
-                  <a:noFill/>
-                </a:ln>
-                <a:solidFill>
-                  <a:schemeClr val="tx1"/>
-                </a:solidFill>
-                <a:effectLst/>
-                <a:latin typeface="Arial" panose="020B0604020202020204" pitchFamily="34" charset="0"/>
-              </a:rPr>
-              <a:t>.</a:t>
-            </a:r>
+              <a:rPr lang="en-US" altLang="en-US" sz="1300">
+                <a:latin typeface="Arial" panose="020B0604020202020204" pitchFamily="34" charset="0"/>
+              </a:rPr>
+              <a:t>Paketi qura</a:t>
+            </a:r>
+            <a:r>
+              <a:rPr lang="az-Latn-AZ" altLang="en-US" sz="1300">
+                <a:latin typeface="Arial" panose="020B0604020202020204" pitchFamily="34" charset="0"/>
+              </a:rPr>
+              <a:t>şdırdıqdan sonra düyməni kliklədikdə </a:t>
+            </a:r>
+            <a:r>
+              <a:rPr lang="az-Latn-AZ" altLang="en-US" sz="1300" b="1">
+                <a:latin typeface="Arial" panose="020B0604020202020204" pitchFamily="34" charset="0"/>
+              </a:rPr>
+              <a:t>EXCEL</a:t>
+            </a:r>
+            <a:r>
+              <a:rPr lang="az-Latn-AZ" altLang="en-US" sz="1300">
+                <a:latin typeface="Arial" panose="020B0604020202020204" pitchFamily="34" charset="0"/>
+              </a:rPr>
+              <a:t> faylı endiriləcəkdir.</a:t>
+            </a:r>
+            <a:endParaRPr kumimoji="0" lang="en-US" altLang="en-US" sz="1300" b="0" i="0" u="none" strike="noStrike" cap="none" normalizeH="0" baseline="0">
+              <a:ln>
+                <a:noFill/>
+              </a:ln>
+              <a:solidFill>
+                <a:schemeClr val="tx1"/>
+              </a:solidFill>
+              <a:effectLst/>
+              <a:latin typeface="Arial" panose="020B0604020202020204" pitchFamily="34" charset="0"/>
+            </a:endParaRPr>
           </a:p>
         </p:txBody>
       </p:sp>
+      <p:pic>
+        <p:nvPicPr>
+          <p:cNvPr id="4" name="Picture 3">
+            <a:extLst>
+              <a:ext uri="{FF2B5EF4-FFF2-40B4-BE49-F238E27FC236}">
+                <a16:creationId xmlns:a16="http://schemas.microsoft.com/office/drawing/2014/main" id="{B95728B6-4AC0-87ED-DD20-4615862966B4}"/>
+              </a:ext>
+            </a:extLst>
+          </p:cNvPr>
+          <p:cNvPicPr>
+            <a:picLocks noChangeAspect="1"/>
+          </p:cNvPicPr>
+          <p:nvPr/>
+        </p:nvPicPr>
+        <p:blipFill>
+          <a:blip r:embed="rId2"/>
+          <a:stretch>
+            <a:fillRect/>
+          </a:stretch>
+        </p:blipFill>
+        <p:spPr>
+          <a:xfrm>
+            <a:off x="-1" y="4085067"/>
+            <a:ext cx="12192000" cy="2772933"/>
+          </a:xfrm>
+          <a:prstGeom prst="rect">
+            <a:avLst/>
+          </a:prstGeom>
+          <a:ln w="38100" cap="sq">
+            <a:solidFill>
+              <a:srgbClr val="000000"/>
+            </a:solidFill>
+            <a:prstDash val="solid"/>
+            <a:miter lim="800000"/>
+          </a:ln>
+          <a:effectLst>
+            <a:outerShdw blurRad="50800" dist="38100" dir="2700000" algn="tl" rotWithShape="0">
+              <a:srgbClr val="000000">
+                <a:alpha val="43000"/>
+              </a:srgbClr>
+            </a:outerShdw>
+          </a:effectLst>
+        </p:spPr>
+      </p:pic>
     </p:spTree>
     <p:extLst>
       <p:ext uri="{BB962C8B-B14F-4D97-AF65-F5344CB8AC3E}">
-        <p14:creationId xmlns:p14="http://schemas.microsoft.com/office/powerpoint/2010/main" val="324630331"/>
+        <p14:creationId xmlns:p14="http://schemas.microsoft.com/office/powerpoint/2010/main" val="2613293729"/>
       </p:ext>
     </p:extLst>
   </p:cSld>
@@ -4407,6 +5978,1588 @@
     <p:extLst>
       <p:ext uri="{BB962C8B-B14F-4D97-AF65-F5344CB8AC3E}">
         <p14:creationId xmlns:p14="http://schemas.microsoft.com/office/powerpoint/2010/main" val="3095838342"/>
+      </p:ext>
+    </p:extLst>
+  </p:cSld>
+  <p:clrMapOvr>
+    <a:masterClrMapping/>
+  </p:clrMapOvr>
+</p:sld>
+</file>
+
+<file path=ppt/slides/slide20.xml><?xml version="1.0" encoding="utf-8"?>
+<p:sld xmlns:a="http://schemas.openxmlformats.org/drawingml/2006/main" xmlns:r="http://schemas.openxmlformats.org/officeDocument/2006/relationships" xmlns:p="http://schemas.openxmlformats.org/presentationml/2006/main">
+  <p:cSld>
+    <p:spTree>
+      <p:nvGrpSpPr>
+        <p:cNvPr id="1" name="">
+          <a:extLst>
+            <a:ext uri="{FF2B5EF4-FFF2-40B4-BE49-F238E27FC236}">
+              <a16:creationId xmlns:a16="http://schemas.microsoft.com/office/drawing/2014/main" id="{598CC416-5DF9-9628-FAC8-49D08B5DE861}"/>
+            </a:ext>
+          </a:extLst>
+        </p:cNvPr>
+        <p:cNvGrpSpPr/>
+        <p:nvPr/>
+      </p:nvGrpSpPr>
+      <p:grpSpPr>
+        <a:xfrm>
+          <a:off x="0" y="0"/>
+          <a:ext cx="0" cy="0"/>
+          <a:chOff x="0" y="0"/>
+          <a:chExt cx="0" cy="0"/>
+        </a:xfrm>
+      </p:grpSpPr>
+      <p:sp>
+        <p:nvSpPr>
+          <p:cNvPr id="3" name="TextBox 2">
+            <a:extLst>
+              <a:ext uri="{FF2B5EF4-FFF2-40B4-BE49-F238E27FC236}">
+                <a16:creationId xmlns:a16="http://schemas.microsoft.com/office/drawing/2014/main" id="{3AACD17A-047E-F53A-0D49-C4118804BAAD}"/>
+              </a:ext>
+            </a:extLst>
+          </p:cNvPr>
+          <p:cNvSpPr txBox="1"/>
+          <p:nvPr/>
+        </p:nvSpPr>
+        <p:spPr>
+          <a:xfrm>
+            <a:off x="217714" y="255046"/>
+            <a:ext cx="11756571" cy="355354"/>
+          </a:xfrm>
+          <a:prstGeom prst="rect">
+            <a:avLst/>
+          </a:prstGeom>
+          <a:noFill/>
+        </p:spPr>
+        <p:txBody>
+          <a:bodyPr wrap="square">
+            <a:spAutoFit/>
+          </a:bodyPr>
+          <a:lstStyle/>
+          <a:p>
+            <a:pPr>
+              <a:lnSpc>
+                <a:spcPct val="150000"/>
+              </a:lnSpc>
+              <a:buNone/>
+            </a:pPr>
+            <a:r>
+              <a:rPr lang="az-Latn-AZ" altLang="en-US" sz="1300">
+                <a:latin typeface="Arial" panose="020B0604020202020204" pitchFamily="34" charset="0"/>
+              </a:rPr>
+              <a:t>Endirilən məluamtlar.</a:t>
+            </a:r>
+            <a:endParaRPr kumimoji="0" lang="en-US" altLang="en-US" sz="1300" b="0" i="0" u="none" strike="noStrike" cap="none" normalizeH="0" baseline="0">
+              <a:ln>
+                <a:noFill/>
+              </a:ln>
+              <a:solidFill>
+                <a:schemeClr val="tx1"/>
+              </a:solidFill>
+              <a:effectLst/>
+              <a:latin typeface="Arial" panose="020B0604020202020204" pitchFamily="34" charset="0"/>
+            </a:endParaRPr>
+          </a:p>
+        </p:txBody>
+      </p:sp>
+      <p:pic>
+        <p:nvPicPr>
+          <p:cNvPr id="4" name="Picture 3">
+            <a:extLst>
+              <a:ext uri="{FF2B5EF4-FFF2-40B4-BE49-F238E27FC236}">
+                <a16:creationId xmlns:a16="http://schemas.microsoft.com/office/drawing/2014/main" id="{F60E93C0-FCA3-F5C8-5AFA-398F02AF3114}"/>
+              </a:ext>
+            </a:extLst>
+          </p:cNvPr>
+          <p:cNvPicPr>
+            <a:picLocks noChangeAspect="1"/>
+          </p:cNvPicPr>
+          <p:nvPr/>
+        </p:nvPicPr>
+        <p:blipFill>
+          <a:blip r:embed="rId2"/>
+          <a:stretch>
+            <a:fillRect/>
+          </a:stretch>
+        </p:blipFill>
+        <p:spPr>
+          <a:xfrm>
+            <a:off x="6236912" y="0"/>
+            <a:ext cx="5955088" cy="6858000"/>
+          </a:xfrm>
+          <a:prstGeom prst="rect">
+            <a:avLst/>
+          </a:prstGeom>
+        </p:spPr>
+      </p:pic>
+    </p:spTree>
+    <p:extLst>
+      <p:ext uri="{BB962C8B-B14F-4D97-AF65-F5344CB8AC3E}">
+        <p14:creationId xmlns:p14="http://schemas.microsoft.com/office/powerpoint/2010/main" val="1221196227"/>
+      </p:ext>
+    </p:extLst>
+  </p:cSld>
+  <p:clrMapOvr>
+    <a:masterClrMapping/>
+  </p:clrMapOvr>
+</p:sld>
+</file>
+
+<file path=ppt/slides/slide21.xml><?xml version="1.0" encoding="utf-8"?>
+<p:sld xmlns:a="http://schemas.openxmlformats.org/drawingml/2006/main" xmlns:r="http://schemas.openxmlformats.org/officeDocument/2006/relationships" xmlns:p="http://schemas.openxmlformats.org/presentationml/2006/main">
+  <p:cSld>
+    <p:spTree>
+      <p:nvGrpSpPr>
+        <p:cNvPr id="1" name="">
+          <a:extLst>
+            <a:ext uri="{FF2B5EF4-FFF2-40B4-BE49-F238E27FC236}">
+              <a16:creationId xmlns:a16="http://schemas.microsoft.com/office/drawing/2014/main" id="{9CEE19E0-D600-72A4-9B4C-6E9A97EB41FA}"/>
+            </a:ext>
+          </a:extLst>
+        </p:cNvPr>
+        <p:cNvGrpSpPr/>
+        <p:nvPr/>
+      </p:nvGrpSpPr>
+      <p:grpSpPr>
+        <a:xfrm>
+          <a:off x="0" y="0"/>
+          <a:ext cx="0" cy="0"/>
+          <a:chOff x="0" y="0"/>
+          <a:chExt cx="0" cy="0"/>
+        </a:xfrm>
+      </p:grpSpPr>
+      <p:sp>
+        <p:nvSpPr>
+          <p:cNvPr id="3" name="TextBox 2">
+            <a:extLst>
+              <a:ext uri="{FF2B5EF4-FFF2-40B4-BE49-F238E27FC236}">
+                <a16:creationId xmlns:a16="http://schemas.microsoft.com/office/drawing/2014/main" id="{03BC0E0D-94B4-87CC-9A0D-0076F8799F52}"/>
+              </a:ext>
+            </a:extLst>
+          </p:cNvPr>
+          <p:cNvSpPr txBox="1"/>
+          <p:nvPr/>
+        </p:nvSpPr>
+        <p:spPr>
+          <a:xfrm>
+            <a:off x="217714" y="255046"/>
+            <a:ext cx="11756571" cy="2756011"/>
+          </a:xfrm>
+          <a:prstGeom prst="rect">
+            <a:avLst/>
+          </a:prstGeom>
+          <a:noFill/>
+        </p:spPr>
+        <p:txBody>
+          <a:bodyPr wrap="square">
+            <a:spAutoFit/>
+          </a:bodyPr>
+          <a:lstStyle/>
+          <a:p>
+            <a:pPr>
+              <a:lnSpc>
+                <a:spcPct val="150000"/>
+              </a:lnSpc>
+              <a:buNone/>
+            </a:pPr>
+            <a:r>
+              <a:rPr lang="en-US" altLang="en-US" sz="1300">
+                <a:latin typeface="Arial" panose="020B0604020202020204" pitchFamily="34" charset="0"/>
+              </a:rPr>
+              <a:t>CSV formatda da datalar</a:t>
+            </a:r>
+            <a:r>
+              <a:rPr lang="az-Latn-AZ" altLang="en-US" sz="1300">
+                <a:latin typeface="Arial" panose="020B0604020202020204" pitchFamily="34" charset="0"/>
+              </a:rPr>
+              <a:t>ı problemsiz endirə bilirik.</a:t>
+            </a:r>
+          </a:p>
+          <a:p>
+            <a:pPr>
+              <a:lnSpc>
+                <a:spcPct val="150000"/>
+              </a:lnSpc>
+              <a:buNone/>
+            </a:pPr>
+            <a:endParaRPr kumimoji="0" lang="az-Latn-AZ" altLang="en-US" sz="1300" b="0" i="0" u="none" strike="noStrike" cap="none" normalizeH="0" baseline="0">
+              <a:ln>
+                <a:noFill/>
+              </a:ln>
+              <a:solidFill>
+                <a:schemeClr val="tx1"/>
+              </a:solidFill>
+              <a:effectLst/>
+              <a:latin typeface="Arial" panose="020B0604020202020204" pitchFamily="34" charset="0"/>
+            </a:endParaRPr>
+          </a:p>
+          <a:p>
+            <a:pPr>
+              <a:lnSpc>
+                <a:spcPct val="150000"/>
+              </a:lnSpc>
+              <a:buNone/>
+            </a:pPr>
+            <a:endParaRPr lang="az-Latn-AZ" altLang="en-US" sz="1300">
+              <a:latin typeface="Arial" panose="020B0604020202020204" pitchFamily="34" charset="0"/>
+            </a:endParaRPr>
+          </a:p>
+          <a:p>
+            <a:pPr>
+              <a:lnSpc>
+                <a:spcPct val="150000"/>
+              </a:lnSpc>
+              <a:buNone/>
+            </a:pPr>
+            <a:endParaRPr kumimoji="0" lang="az-Latn-AZ" altLang="en-US" sz="1300" b="0" i="0" u="none" strike="noStrike" cap="none" normalizeH="0" baseline="0">
+              <a:ln>
+                <a:noFill/>
+              </a:ln>
+              <a:solidFill>
+                <a:schemeClr val="tx1"/>
+              </a:solidFill>
+              <a:effectLst/>
+              <a:latin typeface="Arial" panose="020B0604020202020204" pitchFamily="34" charset="0"/>
+            </a:endParaRPr>
+          </a:p>
+          <a:p>
+            <a:pPr>
+              <a:lnSpc>
+                <a:spcPct val="150000"/>
+              </a:lnSpc>
+              <a:buNone/>
+            </a:pPr>
+            <a:endParaRPr lang="az-Latn-AZ" altLang="en-US" sz="1300">
+              <a:latin typeface="Arial" panose="020B0604020202020204" pitchFamily="34" charset="0"/>
+            </a:endParaRPr>
+          </a:p>
+          <a:p>
+            <a:pPr>
+              <a:lnSpc>
+                <a:spcPct val="150000"/>
+              </a:lnSpc>
+              <a:buNone/>
+            </a:pPr>
+            <a:endParaRPr kumimoji="0" lang="az-Latn-AZ" altLang="en-US" sz="1300" b="0" i="0" u="none" strike="noStrike" cap="none" normalizeH="0" baseline="0">
+              <a:ln>
+                <a:noFill/>
+              </a:ln>
+              <a:solidFill>
+                <a:schemeClr val="tx1"/>
+              </a:solidFill>
+              <a:effectLst/>
+              <a:latin typeface="Arial" panose="020B0604020202020204" pitchFamily="34" charset="0"/>
+            </a:endParaRPr>
+          </a:p>
+          <a:p>
+            <a:pPr>
+              <a:lnSpc>
+                <a:spcPct val="150000"/>
+              </a:lnSpc>
+              <a:buNone/>
+            </a:pPr>
+            <a:endParaRPr lang="az-Latn-AZ" altLang="en-US" sz="1300">
+              <a:latin typeface="Arial" panose="020B0604020202020204" pitchFamily="34" charset="0"/>
+            </a:endParaRPr>
+          </a:p>
+          <a:p>
+            <a:pPr>
+              <a:lnSpc>
+                <a:spcPct val="150000"/>
+              </a:lnSpc>
+              <a:buNone/>
+            </a:pPr>
+            <a:endParaRPr kumimoji="0" lang="az-Latn-AZ" altLang="en-US" sz="1300" b="0" i="0" u="none" strike="noStrike" cap="none" normalizeH="0" baseline="0">
+              <a:ln>
+                <a:noFill/>
+              </a:ln>
+              <a:solidFill>
+                <a:schemeClr val="tx1"/>
+              </a:solidFill>
+              <a:effectLst/>
+              <a:latin typeface="Arial" panose="020B0604020202020204" pitchFamily="34" charset="0"/>
+            </a:endParaRPr>
+          </a:p>
+          <a:p>
+            <a:pPr>
+              <a:lnSpc>
+                <a:spcPct val="150000"/>
+              </a:lnSpc>
+              <a:buNone/>
+            </a:pPr>
+            <a:r>
+              <a:rPr lang="az-Latn-AZ" altLang="en-US" sz="1300">
+                <a:latin typeface="Arial" panose="020B0604020202020204" pitchFamily="34" charset="0"/>
+              </a:rPr>
+              <a:t>Ancaq </a:t>
+            </a:r>
+            <a:r>
+              <a:rPr lang="az-Latn-AZ" altLang="en-US" sz="1300" b="1">
+                <a:latin typeface="Arial" panose="020B0604020202020204" pitchFamily="34" charset="0"/>
+              </a:rPr>
+              <a:t>PDF</a:t>
+            </a:r>
+            <a:r>
+              <a:rPr lang="az-Latn-AZ" altLang="en-US" sz="1300">
+                <a:latin typeface="Arial" panose="020B0604020202020204" pitchFamily="34" charset="0"/>
+              </a:rPr>
+              <a:t> fromatı üçün `</a:t>
+            </a:r>
+            <a:r>
+              <a:rPr lang="az-Latn-AZ" altLang="en-US" sz="1300" b="1">
+                <a:solidFill>
+                  <a:srgbClr val="FF0000"/>
+                </a:solidFill>
+                <a:latin typeface="Arial" panose="020B0604020202020204" pitchFamily="34" charset="0"/>
+              </a:rPr>
+              <a:t>barryvdh/laravel-snappy</a:t>
+            </a:r>
+            <a:r>
+              <a:rPr lang="az-Latn-AZ" altLang="en-US" sz="1300">
+                <a:latin typeface="Arial" panose="020B0604020202020204" pitchFamily="34" charset="0"/>
+              </a:rPr>
+              <a:t>` adlı paket endirmək lazımdır: </a:t>
+            </a:r>
+            <a:r>
+              <a:rPr lang="az-Latn-AZ" altLang="en-US" sz="1300" u="sng">
+                <a:solidFill>
+                  <a:srgbClr val="00B0F0"/>
+                </a:solidFill>
+                <a:latin typeface="Arial" panose="020B0604020202020204" pitchFamily="34" charset="0"/>
+              </a:rPr>
+              <a:t>https://github.com/barryvdh/laravel-snappy</a:t>
+            </a:r>
+            <a:r>
+              <a:rPr lang="az-Latn-AZ" altLang="en-US" sz="1300">
+                <a:latin typeface="Arial" panose="020B0604020202020204" pitchFamily="34" charset="0"/>
+              </a:rPr>
+              <a:t> . Ardı var.....</a:t>
+            </a:r>
+            <a:endParaRPr kumimoji="0" lang="en-US" altLang="en-US" sz="1300" b="0" i="0" u="none" strike="noStrike" cap="none" normalizeH="0" baseline="0">
+              <a:ln>
+                <a:noFill/>
+              </a:ln>
+              <a:solidFill>
+                <a:schemeClr val="tx1"/>
+              </a:solidFill>
+              <a:effectLst/>
+              <a:latin typeface="Arial" panose="020B0604020202020204" pitchFamily="34" charset="0"/>
+            </a:endParaRPr>
+          </a:p>
+        </p:txBody>
+      </p:sp>
+      <p:pic>
+        <p:nvPicPr>
+          <p:cNvPr id="4" name="Picture 3">
+            <a:extLst>
+              <a:ext uri="{FF2B5EF4-FFF2-40B4-BE49-F238E27FC236}">
+                <a16:creationId xmlns:a16="http://schemas.microsoft.com/office/drawing/2014/main" id="{3B10A200-F58B-7EEC-1AE9-8A9D8CBC8327}"/>
+              </a:ext>
+            </a:extLst>
+          </p:cNvPr>
+          <p:cNvPicPr>
+            <a:picLocks noChangeAspect="1"/>
+          </p:cNvPicPr>
+          <p:nvPr/>
+        </p:nvPicPr>
+        <p:blipFill>
+          <a:blip r:embed="rId2"/>
+          <a:stretch>
+            <a:fillRect/>
+          </a:stretch>
+        </p:blipFill>
+        <p:spPr>
+          <a:xfrm>
+            <a:off x="217714" y="653765"/>
+            <a:ext cx="2021633" cy="649550"/>
+          </a:xfrm>
+          <a:prstGeom prst="rect">
+            <a:avLst/>
+          </a:prstGeom>
+          <a:ln w="38100" cap="sq">
+            <a:solidFill>
+              <a:srgbClr val="000000"/>
+            </a:solidFill>
+            <a:prstDash val="solid"/>
+            <a:miter lim="800000"/>
+          </a:ln>
+          <a:effectLst>
+            <a:outerShdw blurRad="50800" dist="38100" dir="2700000" algn="tl" rotWithShape="0">
+              <a:srgbClr val="000000">
+                <a:alpha val="43000"/>
+              </a:srgbClr>
+            </a:outerShdw>
+          </a:effectLst>
+        </p:spPr>
+      </p:pic>
+      <p:pic>
+        <p:nvPicPr>
+          <p:cNvPr id="6" name="Picture 5">
+            <a:extLst>
+              <a:ext uri="{FF2B5EF4-FFF2-40B4-BE49-F238E27FC236}">
+                <a16:creationId xmlns:a16="http://schemas.microsoft.com/office/drawing/2014/main" id="{F8C94E25-96EE-87B7-07F7-E0CC758E0A29}"/>
+              </a:ext>
+            </a:extLst>
+          </p:cNvPr>
+          <p:cNvPicPr>
+            <a:picLocks noChangeAspect="1"/>
+          </p:cNvPicPr>
+          <p:nvPr/>
+        </p:nvPicPr>
+        <p:blipFill>
+          <a:blip r:embed="rId3"/>
+          <a:stretch>
+            <a:fillRect/>
+          </a:stretch>
+        </p:blipFill>
+        <p:spPr>
+          <a:xfrm>
+            <a:off x="217714" y="3159025"/>
+            <a:ext cx="2198915" cy="645931"/>
+          </a:xfrm>
+          <a:prstGeom prst="rect">
+            <a:avLst/>
+          </a:prstGeom>
+          <a:ln w="38100" cap="sq">
+            <a:solidFill>
+              <a:srgbClr val="000000"/>
+            </a:solidFill>
+            <a:prstDash val="solid"/>
+            <a:miter lim="800000"/>
+          </a:ln>
+          <a:effectLst>
+            <a:outerShdw blurRad="50800" dist="38100" dir="2700000" algn="tl" rotWithShape="0">
+              <a:srgbClr val="000000">
+                <a:alpha val="43000"/>
+              </a:srgbClr>
+            </a:outerShdw>
+          </a:effectLst>
+        </p:spPr>
+      </p:pic>
+      <p:pic>
+        <p:nvPicPr>
+          <p:cNvPr id="8" name="Picture 7">
+            <a:extLst>
+              <a:ext uri="{FF2B5EF4-FFF2-40B4-BE49-F238E27FC236}">
+                <a16:creationId xmlns:a16="http://schemas.microsoft.com/office/drawing/2014/main" id="{50CEE98C-5322-0174-8247-C4E2D414D5B7}"/>
+              </a:ext>
+            </a:extLst>
+          </p:cNvPr>
+          <p:cNvPicPr>
+            <a:picLocks noChangeAspect="1"/>
+          </p:cNvPicPr>
+          <p:nvPr/>
+        </p:nvPicPr>
+        <p:blipFill>
+          <a:blip r:embed="rId4"/>
+          <a:stretch>
+            <a:fillRect/>
+          </a:stretch>
+        </p:blipFill>
+        <p:spPr>
+          <a:xfrm>
+            <a:off x="217715" y="3952924"/>
+            <a:ext cx="4534616" cy="629451"/>
+          </a:xfrm>
+          <a:prstGeom prst="rect">
+            <a:avLst/>
+          </a:prstGeom>
+        </p:spPr>
+      </p:pic>
+      <p:pic>
+        <p:nvPicPr>
+          <p:cNvPr id="12" name="Picture 11">
+            <a:extLst>
+              <a:ext uri="{FF2B5EF4-FFF2-40B4-BE49-F238E27FC236}">
+                <a16:creationId xmlns:a16="http://schemas.microsoft.com/office/drawing/2014/main" id="{95974D68-8D24-05C2-DA3D-2E42644AB241}"/>
+              </a:ext>
+            </a:extLst>
+          </p:cNvPr>
+          <p:cNvPicPr>
+            <a:picLocks noChangeAspect="1"/>
+          </p:cNvPicPr>
+          <p:nvPr/>
+        </p:nvPicPr>
+        <p:blipFill>
+          <a:blip r:embed="rId5"/>
+          <a:stretch>
+            <a:fillRect/>
+          </a:stretch>
+        </p:blipFill>
+        <p:spPr>
+          <a:xfrm>
+            <a:off x="217714" y="4746822"/>
+            <a:ext cx="3222734" cy="2111177"/>
+          </a:xfrm>
+          <a:prstGeom prst="rect">
+            <a:avLst/>
+          </a:prstGeom>
+        </p:spPr>
+      </p:pic>
+    </p:spTree>
+    <p:extLst>
+      <p:ext uri="{BB962C8B-B14F-4D97-AF65-F5344CB8AC3E}">
+        <p14:creationId xmlns:p14="http://schemas.microsoft.com/office/powerpoint/2010/main" val="2295731596"/>
+      </p:ext>
+    </p:extLst>
+  </p:cSld>
+  <p:clrMapOvr>
+    <a:masterClrMapping/>
+  </p:clrMapOvr>
+</p:sld>
+</file>
+
+<file path=ppt/slides/slide22.xml><?xml version="1.0" encoding="utf-8"?>
+<p:sld xmlns:a="http://schemas.openxmlformats.org/drawingml/2006/main" xmlns:r="http://schemas.openxmlformats.org/officeDocument/2006/relationships" xmlns:p="http://schemas.openxmlformats.org/presentationml/2006/main">
+  <p:cSld>
+    <p:spTree>
+      <p:nvGrpSpPr>
+        <p:cNvPr id="1" name="">
+          <a:extLst>
+            <a:ext uri="{FF2B5EF4-FFF2-40B4-BE49-F238E27FC236}">
+              <a16:creationId xmlns:a16="http://schemas.microsoft.com/office/drawing/2014/main" id="{01481488-C81F-AE33-C49B-06D014F38BC4}"/>
+            </a:ext>
+          </a:extLst>
+        </p:cNvPr>
+        <p:cNvGrpSpPr/>
+        <p:nvPr/>
+      </p:nvGrpSpPr>
+      <p:grpSpPr>
+        <a:xfrm>
+          <a:off x="0" y="0"/>
+          <a:ext cx="0" cy="0"/>
+          <a:chOff x="0" y="0"/>
+          <a:chExt cx="0" cy="0"/>
+        </a:xfrm>
+      </p:grpSpPr>
+      <p:sp>
+        <p:nvSpPr>
+          <p:cNvPr id="3" name="TextBox 2">
+            <a:extLst>
+              <a:ext uri="{FF2B5EF4-FFF2-40B4-BE49-F238E27FC236}">
+                <a16:creationId xmlns:a16="http://schemas.microsoft.com/office/drawing/2014/main" id="{5B3BB690-DF5A-9790-66AF-85BF41DAA037}"/>
+              </a:ext>
+            </a:extLst>
+          </p:cNvPr>
+          <p:cNvSpPr txBox="1"/>
+          <p:nvPr/>
+        </p:nvSpPr>
+        <p:spPr>
+          <a:xfrm>
+            <a:off x="217714" y="255046"/>
+            <a:ext cx="11756571" cy="4948919"/>
+          </a:xfrm>
+          <a:prstGeom prst="rect">
+            <a:avLst/>
+          </a:prstGeom>
+          <a:noFill/>
+        </p:spPr>
+        <p:txBody>
+          <a:bodyPr wrap="square">
+            <a:spAutoFit/>
+          </a:bodyPr>
+          <a:lstStyle/>
+          <a:p>
+            <a:pPr>
+              <a:lnSpc>
+                <a:spcPct val="150000"/>
+              </a:lnSpc>
+              <a:buNone/>
+            </a:pPr>
+            <a:r>
+              <a:rPr lang="az-Latn-AZ" altLang="en-US" sz="1300">
+                <a:latin typeface="Arial" panose="020B0604020202020204" pitchFamily="34" charset="0"/>
+              </a:rPr>
+              <a:t>Növbəti xəta `</a:t>
+            </a:r>
+            <a:r>
+              <a:rPr lang="az-Latn-AZ" altLang="en-US" sz="1300" b="1">
+                <a:solidFill>
+                  <a:srgbClr val="FF0000"/>
+                </a:solidFill>
+                <a:latin typeface="Arial" panose="020B0604020202020204" pitchFamily="34" charset="0"/>
+              </a:rPr>
+              <a:t>wkhtmltopdf</a:t>
+            </a:r>
+            <a:r>
+              <a:rPr lang="az-Latn-AZ" altLang="en-US" sz="1300">
+                <a:latin typeface="Arial" panose="020B0604020202020204" pitchFamily="34" charset="0"/>
+              </a:rPr>
+              <a:t>` ilə əlaqəlidir: </a:t>
+            </a:r>
+            <a:r>
+              <a:rPr lang="az-Latn-AZ" altLang="en-US" sz="1300" u="sng">
+                <a:solidFill>
+                  <a:srgbClr val="00B0F0"/>
+                </a:solidFill>
+                <a:latin typeface="Arial" panose="020B0604020202020204" pitchFamily="34" charset="0"/>
+              </a:rPr>
+              <a:t>https://wkhtmltopdf.org</a:t>
+            </a:r>
+            <a:r>
+              <a:rPr lang="az-Latn-AZ" altLang="en-US" sz="1300">
+                <a:latin typeface="Arial" panose="020B0604020202020204" pitchFamily="34" charset="0"/>
+              </a:rPr>
+              <a:t> .           </a:t>
+            </a:r>
+            <a:r>
+              <a:rPr lang="az-Latn-AZ" altLang="en-US" sz="1300" u="sng">
+                <a:solidFill>
+                  <a:srgbClr val="00B0F0"/>
+                </a:solidFill>
+                <a:latin typeface="Arial" panose="020B0604020202020204" pitchFamily="34" charset="0"/>
+              </a:rPr>
+              <a:t>https://wkhtmltopdf.org/downloads.html</a:t>
+            </a:r>
+            <a:r>
+              <a:rPr lang="az-Latn-AZ" altLang="en-US" sz="1300">
+                <a:latin typeface="Arial" panose="020B0604020202020204" pitchFamily="34" charset="0"/>
+              </a:rPr>
+              <a:t> .</a:t>
+            </a:r>
+          </a:p>
+          <a:p>
+            <a:pPr>
+              <a:lnSpc>
+                <a:spcPct val="150000"/>
+              </a:lnSpc>
+              <a:buNone/>
+            </a:pPr>
+            <a:endParaRPr kumimoji="0" lang="az-Latn-AZ" altLang="en-US" sz="800" b="0" i="0" u="none" strike="noStrike" cap="none" normalizeH="0" baseline="0">
+              <a:ln>
+                <a:noFill/>
+              </a:ln>
+              <a:solidFill>
+                <a:schemeClr val="tx1"/>
+              </a:solidFill>
+              <a:effectLst/>
+              <a:latin typeface="Arial" panose="020B0604020202020204" pitchFamily="34" charset="0"/>
+            </a:endParaRPr>
+          </a:p>
+          <a:p>
+            <a:pPr>
+              <a:lnSpc>
+                <a:spcPct val="150000"/>
+              </a:lnSpc>
+              <a:buNone/>
+            </a:pPr>
+            <a:r>
+              <a:rPr lang="en-US" altLang="en-US" sz="1300" b="1">
+                <a:latin typeface="Arial" panose="020B0604020202020204" pitchFamily="34" charset="0"/>
+              </a:rPr>
+              <a:t>wkhtmltopdf</a:t>
+            </a:r>
+            <a:r>
+              <a:rPr lang="en-US" altLang="en-US" sz="1300">
+                <a:latin typeface="Arial" panose="020B0604020202020204" pitchFamily="34" charset="0"/>
+              </a:rPr>
+              <a:t> — HTML sənədlərini PDF formatına çevirən bir komanda sətri (CLI) alətidir. O, WebKit (Qt) render mühərrikindən istifadə edərək, veb səhifənin vizual görünüşünü PDF sənədinə çevirməyə imkan verir.</a:t>
+            </a:r>
+            <a:r>
+              <a:rPr lang="az-Latn-AZ" altLang="en-US" sz="1300">
+                <a:latin typeface="Arial" panose="020B0604020202020204" pitchFamily="34" charset="0"/>
+              </a:rPr>
+              <a:t> </a:t>
+            </a:r>
+          </a:p>
+          <a:p>
+            <a:pPr>
+              <a:lnSpc>
+                <a:spcPct val="150000"/>
+              </a:lnSpc>
+              <a:buNone/>
+            </a:pPr>
+            <a:endParaRPr kumimoji="0" lang="az-Latn-AZ" altLang="en-US" sz="900" b="0" i="0" u="none" strike="noStrike" cap="none" normalizeH="0" baseline="0">
+              <a:ln>
+                <a:noFill/>
+              </a:ln>
+              <a:solidFill>
+                <a:schemeClr val="tx1"/>
+              </a:solidFill>
+              <a:effectLst/>
+              <a:latin typeface="Arial" panose="020B0604020202020204" pitchFamily="34" charset="0"/>
+            </a:endParaRPr>
+          </a:p>
+          <a:p>
+            <a:pPr>
+              <a:lnSpc>
+                <a:spcPct val="150000"/>
+              </a:lnSpc>
+              <a:buNone/>
+            </a:pPr>
+            <a:r>
+              <a:rPr lang="en-US" altLang="en-US" sz="1300">
+                <a:latin typeface="Arial" panose="020B0604020202020204" pitchFamily="34" charset="0"/>
+              </a:rPr>
+              <a:t>Laravel-də bu alət ən çox </a:t>
+            </a:r>
+            <a:r>
+              <a:rPr lang="en-US" altLang="en-US" sz="1300" b="1">
+                <a:latin typeface="Arial" panose="020B0604020202020204" pitchFamily="34" charset="0"/>
+              </a:rPr>
+              <a:t>barryvdh/laravel-snappy </a:t>
+            </a:r>
+            <a:r>
+              <a:rPr lang="en-US" altLang="en-US" sz="1300">
+                <a:latin typeface="Arial" panose="020B0604020202020204" pitchFamily="34" charset="0"/>
+              </a:rPr>
+              <a:t>paketi ilə birlikdə istifadə olunur.</a:t>
+            </a:r>
+            <a:endParaRPr lang="az-Latn-AZ" altLang="en-US" sz="1300">
+              <a:latin typeface="Arial" panose="020B0604020202020204" pitchFamily="34" charset="0"/>
+            </a:endParaRPr>
+          </a:p>
+          <a:p>
+            <a:pPr>
+              <a:lnSpc>
+                <a:spcPct val="150000"/>
+              </a:lnSpc>
+              <a:buNone/>
+            </a:pPr>
+            <a:endParaRPr kumimoji="0" lang="az-Latn-AZ" altLang="en-US" sz="1300" b="0" i="0" u="none" strike="noStrike" cap="none" normalizeH="0" baseline="0">
+              <a:ln>
+                <a:noFill/>
+              </a:ln>
+              <a:solidFill>
+                <a:schemeClr val="tx1"/>
+              </a:solidFill>
+              <a:effectLst/>
+              <a:latin typeface="Arial" panose="020B0604020202020204" pitchFamily="34" charset="0"/>
+            </a:endParaRPr>
+          </a:p>
+          <a:p>
+            <a:pPr>
+              <a:lnSpc>
+                <a:spcPct val="150000"/>
+              </a:lnSpc>
+              <a:buNone/>
+            </a:pPr>
+            <a:endParaRPr lang="az-Latn-AZ" altLang="en-US" sz="1300">
+              <a:latin typeface="Arial" panose="020B0604020202020204" pitchFamily="34" charset="0"/>
+            </a:endParaRPr>
+          </a:p>
+          <a:p>
+            <a:pPr>
+              <a:lnSpc>
+                <a:spcPct val="150000"/>
+              </a:lnSpc>
+              <a:buNone/>
+            </a:pPr>
+            <a:endParaRPr kumimoji="0" lang="az-Latn-AZ" altLang="en-US" sz="1300" b="0" i="0" u="none" strike="noStrike" cap="none" normalizeH="0" baseline="0">
+              <a:ln>
+                <a:noFill/>
+              </a:ln>
+              <a:solidFill>
+                <a:schemeClr val="tx1"/>
+              </a:solidFill>
+              <a:effectLst/>
+              <a:latin typeface="Arial" panose="020B0604020202020204" pitchFamily="34" charset="0"/>
+            </a:endParaRPr>
+          </a:p>
+          <a:p>
+            <a:pPr>
+              <a:lnSpc>
+                <a:spcPct val="150000"/>
+              </a:lnSpc>
+              <a:buNone/>
+            </a:pPr>
+            <a:endParaRPr lang="az-Latn-AZ" altLang="en-US" sz="1300">
+              <a:latin typeface="Arial" panose="020B0604020202020204" pitchFamily="34" charset="0"/>
+            </a:endParaRPr>
+          </a:p>
+          <a:p>
+            <a:pPr>
+              <a:lnSpc>
+                <a:spcPct val="150000"/>
+              </a:lnSpc>
+              <a:buNone/>
+            </a:pPr>
+            <a:endParaRPr kumimoji="0" lang="az-Latn-AZ" altLang="en-US" sz="1300" b="0" i="0" u="none" strike="noStrike" cap="none" normalizeH="0" baseline="0">
+              <a:ln>
+                <a:noFill/>
+              </a:ln>
+              <a:solidFill>
+                <a:schemeClr val="tx1"/>
+              </a:solidFill>
+              <a:effectLst/>
+              <a:latin typeface="Arial" panose="020B0604020202020204" pitchFamily="34" charset="0"/>
+            </a:endParaRPr>
+          </a:p>
+          <a:p>
+            <a:pPr>
+              <a:lnSpc>
+                <a:spcPct val="150000"/>
+              </a:lnSpc>
+              <a:buNone/>
+            </a:pPr>
+            <a:endParaRPr lang="az-Latn-AZ" altLang="en-US" sz="1300">
+              <a:latin typeface="Arial" panose="020B0604020202020204" pitchFamily="34" charset="0"/>
+            </a:endParaRPr>
+          </a:p>
+          <a:p>
+            <a:pPr>
+              <a:lnSpc>
+                <a:spcPct val="150000"/>
+              </a:lnSpc>
+              <a:buNone/>
+            </a:pPr>
+            <a:endParaRPr kumimoji="0" lang="az-Latn-AZ" altLang="en-US" sz="1300" b="0" i="0" u="none" strike="noStrike" cap="none" normalizeH="0" baseline="0">
+              <a:ln>
+                <a:noFill/>
+              </a:ln>
+              <a:solidFill>
+                <a:schemeClr val="tx1"/>
+              </a:solidFill>
+              <a:effectLst/>
+              <a:latin typeface="Arial" panose="020B0604020202020204" pitchFamily="34" charset="0"/>
+            </a:endParaRPr>
+          </a:p>
+          <a:p>
+            <a:pPr>
+              <a:lnSpc>
+                <a:spcPct val="150000"/>
+              </a:lnSpc>
+              <a:buNone/>
+            </a:pPr>
+            <a:endParaRPr lang="az-Latn-AZ" altLang="en-US" sz="1300">
+              <a:latin typeface="Arial" panose="020B0604020202020204" pitchFamily="34" charset="0"/>
+            </a:endParaRPr>
+          </a:p>
+          <a:p>
+            <a:pPr>
+              <a:lnSpc>
+                <a:spcPct val="150000"/>
+              </a:lnSpc>
+              <a:buNone/>
+            </a:pPr>
+            <a:endParaRPr kumimoji="0" lang="az-Latn-AZ" altLang="en-US" sz="1300" b="0" i="0" u="none" strike="noStrike" cap="none" normalizeH="0" baseline="0">
+              <a:ln>
+                <a:noFill/>
+              </a:ln>
+              <a:solidFill>
+                <a:schemeClr val="tx1"/>
+              </a:solidFill>
+              <a:effectLst/>
+              <a:latin typeface="Arial" panose="020B0604020202020204" pitchFamily="34" charset="0"/>
+            </a:endParaRPr>
+          </a:p>
+          <a:p>
+            <a:pPr>
+              <a:lnSpc>
+                <a:spcPct val="150000"/>
+              </a:lnSpc>
+              <a:buNone/>
+            </a:pPr>
+            <a:endParaRPr kumimoji="0" lang="az-Latn-AZ" altLang="en-US" sz="700" b="0" i="0" u="none" strike="noStrike" cap="none" normalizeH="0" baseline="0">
+              <a:ln>
+                <a:noFill/>
+              </a:ln>
+              <a:solidFill>
+                <a:schemeClr val="tx1"/>
+              </a:solidFill>
+              <a:effectLst/>
+              <a:latin typeface="Arial" panose="020B0604020202020204" pitchFamily="34" charset="0"/>
+            </a:endParaRPr>
+          </a:p>
+          <a:p>
+            <a:pPr>
+              <a:lnSpc>
+                <a:spcPct val="150000"/>
+              </a:lnSpc>
+              <a:buNone/>
+            </a:pPr>
+            <a:r>
+              <a:rPr lang="az-Latn-AZ" altLang="en-US" sz="1300">
+                <a:latin typeface="Arial" panose="020B0604020202020204" pitchFamily="34" charset="0"/>
+              </a:rPr>
+              <a:t>Proqramı endiririk və quraşdırırıq.</a:t>
+            </a:r>
+            <a:endParaRPr kumimoji="0" lang="en-US" altLang="en-US" sz="1300" b="0" i="0" u="none" strike="noStrike" cap="none" normalizeH="0" baseline="0">
+              <a:ln>
+                <a:noFill/>
+              </a:ln>
+              <a:solidFill>
+                <a:schemeClr val="tx1"/>
+              </a:solidFill>
+              <a:effectLst/>
+              <a:latin typeface="Arial" panose="020B0604020202020204" pitchFamily="34" charset="0"/>
+            </a:endParaRPr>
+          </a:p>
+        </p:txBody>
+      </p:sp>
+      <p:pic>
+        <p:nvPicPr>
+          <p:cNvPr id="4" name="Picture 3">
+            <a:extLst>
+              <a:ext uri="{FF2B5EF4-FFF2-40B4-BE49-F238E27FC236}">
+                <a16:creationId xmlns:a16="http://schemas.microsoft.com/office/drawing/2014/main" id="{85B08A70-5942-F473-1B2A-F699D54D1C64}"/>
+              </a:ext>
+            </a:extLst>
+          </p:cNvPr>
+          <p:cNvPicPr>
+            <a:picLocks noChangeAspect="1"/>
+          </p:cNvPicPr>
+          <p:nvPr/>
+        </p:nvPicPr>
+        <p:blipFill>
+          <a:blip r:embed="rId2"/>
+          <a:stretch>
+            <a:fillRect/>
+          </a:stretch>
+        </p:blipFill>
+        <p:spPr>
+          <a:xfrm>
+            <a:off x="-1" y="1949228"/>
+            <a:ext cx="12192000" cy="2605698"/>
+          </a:xfrm>
+          <a:prstGeom prst="rect">
+            <a:avLst/>
+          </a:prstGeom>
+        </p:spPr>
+      </p:pic>
+      <p:pic>
+        <p:nvPicPr>
+          <p:cNvPr id="9" name="Picture 8">
+            <a:extLst>
+              <a:ext uri="{FF2B5EF4-FFF2-40B4-BE49-F238E27FC236}">
+                <a16:creationId xmlns:a16="http://schemas.microsoft.com/office/drawing/2014/main" id="{9BAC047B-7900-3508-3BAF-A66F9B2DB207}"/>
+              </a:ext>
+            </a:extLst>
+          </p:cNvPr>
+          <p:cNvPicPr>
+            <a:picLocks noChangeAspect="1"/>
+          </p:cNvPicPr>
+          <p:nvPr/>
+        </p:nvPicPr>
+        <p:blipFill>
+          <a:blip r:embed="rId3"/>
+          <a:stretch>
+            <a:fillRect/>
+          </a:stretch>
+        </p:blipFill>
+        <p:spPr>
+          <a:xfrm>
+            <a:off x="0" y="5108075"/>
+            <a:ext cx="12192000" cy="1749925"/>
+          </a:xfrm>
+          <a:prstGeom prst="rect">
+            <a:avLst/>
+          </a:prstGeom>
+          <a:ln w="38100" cap="sq">
+            <a:solidFill>
+              <a:srgbClr val="000000"/>
+            </a:solidFill>
+            <a:prstDash val="solid"/>
+            <a:miter lim="800000"/>
+          </a:ln>
+          <a:effectLst>
+            <a:outerShdw blurRad="50800" dist="38100" dir="2700000" algn="tl" rotWithShape="0">
+              <a:srgbClr val="000000">
+                <a:alpha val="43000"/>
+              </a:srgbClr>
+            </a:outerShdw>
+          </a:effectLst>
+        </p:spPr>
+      </p:pic>
+    </p:spTree>
+    <p:extLst>
+      <p:ext uri="{BB962C8B-B14F-4D97-AF65-F5344CB8AC3E}">
+        <p14:creationId xmlns:p14="http://schemas.microsoft.com/office/powerpoint/2010/main" val="3584570892"/>
+      </p:ext>
+    </p:extLst>
+  </p:cSld>
+  <p:clrMapOvr>
+    <a:masterClrMapping/>
+  </p:clrMapOvr>
+</p:sld>
+</file>
+
+<file path=ppt/slides/slide23.xml><?xml version="1.0" encoding="utf-8"?>
+<p:sld xmlns:a="http://schemas.openxmlformats.org/drawingml/2006/main" xmlns:r="http://schemas.openxmlformats.org/officeDocument/2006/relationships" xmlns:p="http://schemas.openxmlformats.org/presentationml/2006/main">
+  <p:cSld>
+    <p:spTree>
+      <p:nvGrpSpPr>
+        <p:cNvPr id="1" name="">
+          <a:extLst>
+            <a:ext uri="{FF2B5EF4-FFF2-40B4-BE49-F238E27FC236}">
+              <a16:creationId xmlns:a16="http://schemas.microsoft.com/office/drawing/2014/main" id="{A5F4F258-E547-CB58-42C9-E9D2F3DAB2D5}"/>
+            </a:ext>
+          </a:extLst>
+        </p:cNvPr>
+        <p:cNvGrpSpPr/>
+        <p:nvPr/>
+      </p:nvGrpSpPr>
+      <p:grpSpPr>
+        <a:xfrm>
+          <a:off x="0" y="0"/>
+          <a:ext cx="0" cy="0"/>
+          <a:chOff x="0" y="0"/>
+          <a:chExt cx="0" cy="0"/>
+        </a:xfrm>
+      </p:grpSpPr>
+      <p:sp>
+        <p:nvSpPr>
+          <p:cNvPr id="3" name="TextBox 2">
+            <a:extLst>
+              <a:ext uri="{FF2B5EF4-FFF2-40B4-BE49-F238E27FC236}">
+                <a16:creationId xmlns:a16="http://schemas.microsoft.com/office/drawing/2014/main" id="{5EF446E3-BC00-25BD-7E9B-7088866001C4}"/>
+              </a:ext>
+            </a:extLst>
+          </p:cNvPr>
+          <p:cNvSpPr txBox="1"/>
+          <p:nvPr/>
+        </p:nvSpPr>
+        <p:spPr>
+          <a:xfrm>
+            <a:off x="217714" y="255046"/>
+            <a:ext cx="11756571" cy="355354"/>
+          </a:xfrm>
+          <a:prstGeom prst="rect">
+            <a:avLst/>
+          </a:prstGeom>
+          <a:noFill/>
+        </p:spPr>
+        <p:txBody>
+          <a:bodyPr wrap="square">
+            <a:spAutoFit/>
+          </a:bodyPr>
+          <a:lstStyle/>
+          <a:p>
+            <a:pPr>
+              <a:lnSpc>
+                <a:spcPct val="150000"/>
+              </a:lnSpc>
+              <a:buNone/>
+            </a:pPr>
+            <a:r>
+              <a:rPr lang="az-Latn-AZ" altLang="en-US" sz="1300">
+                <a:latin typeface="Arial" panose="020B0604020202020204" pitchFamily="34" charset="0"/>
+              </a:rPr>
+              <a:t>Endirmə tamamlandıqdan sonra növbəti sətri </a:t>
+            </a:r>
+            <a:r>
+              <a:rPr lang="en-US" altLang="en-US" sz="1300">
+                <a:latin typeface="Arial" panose="020B0604020202020204" pitchFamily="34" charset="0"/>
+              </a:rPr>
+              <a:t>`</a:t>
+            </a:r>
+            <a:r>
+              <a:rPr lang="en-US" altLang="en-US" sz="1300" b="1">
+                <a:latin typeface="Arial" panose="020B0604020202020204" pitchFamily="34" charset="0"/>
+              </a:rPr>
+              <a:t>config\snappy.php</a:t>
+            </a:r>
+            <a:r>
+              <a:rPr lang="en-US" altLang="en-US" sz="1300">
+                <a:latin typeface="Arial" panose="020B0604020202020204" pitchFamily="34" charset="0"/>
+              </a:rPr>
+              <a:t>` </a:t>
+            </a:r>
+            <a:r>
+              <a:rPr lang="az-Latn-AZ" altLang="en-US" sz="1300">
+                <a:latin typeface="Arial" panose="020B0604020202020204" pitchFamily="34" charset="0"/>
+              </a:rPr>
+              <a:t>faylına əlavə edirik.</a:t>
+            </a:r>
+            <a:endParaRPr kumimoji="0" lang="en-US" altLang="en-US" sz="1300" b="0" i="0" u="none" strike="noStrike" cap="none" normalizeH="0" baseline="0">
+              <a:ln>
+                <a:noFill/>
+              </a:ln>
+              <a:solidFill>
+                <a:schemeClr val="tx1"/>
+              </a:solidFill>
+              <a:effectLst/>
+              <a:latin typeface="Arial" panose="020B0604020202020204" pitchFamily="34" charset="0"/>
+            </a:endParaRPr>
+          </a:p>
+        </p:txBody>
+      </p:sp>
+      <p:pic>
+        <p:nvPicPr>
+          <p:cNvPr id="4" name="Picture 3">
+            <a:extLst>
+              <a:ext uri="{FF2B5EF4-FFF2-40B4-BE49-F238E27FC236}">
+                <a16:creationId xmlns:a16="http://schemas.microsoft.com/office/drawing/2014/main" id="{D64FA2F4-8ACB-62FA-A1BB-2B60FDBBB59E}"/>
+              </a:ext>
+            </a:extLst>
+          </p:cNvPr>
+          <p:cNvPicPr>
+            <a:picLocks noChangeAspect="1"/>
+          </p:cNvPicPr>
+          <p:nvPr/>
+        </p:nvPicPr>
+        <p:blipFill>
+          <a:blip r:embed="rId2"/>
+          <a:stretch>
+            <a:fillRect/>
+          </a:stretch>
+        </p:blipFill>
+        <p:spPr>
+          <a:xfrm>
+            <a:off x="18201" y="730667"/>
+            <a:ext cx="12155596" cy="3038899"/>
+          </a:xfrm>
+          <a:prstGeom prst="rect">
+            <a:avLst/>
+          </a:prstGeom>
+        </p:spPr>
+      </p:pic>
+      <p:pic>
+        <p:nvPicPr>
+          <p:cNvPr id="6" name="Picture 5">
+            <a:extLst>
+              <a:ext uri="{FF2B5EF4-FFF2-40B4-BE49-F238E27FC236}">
+                <a16:creationId xmlns:a16="http://schemas.microsoft.com/office/drawing/2014/main" id="{03471B82-F4B0-13F8-DB4B-D8E8FF7FC83C}"/>
+              </a:ext>
+            </a:extLst>
+          </p:cNvPr>
+          <p:cNvPicPr>
+            <a:picLocks noChangeAspect="1"/>
+          </p:cNvPicPr>
+          <p:nvPr/>
+        </p:nvPicPr>
+        <p:blipFill>
+          <a:blip r:embed="rId3"/>
+          <a:stretch>
+            <a:fillRect/>
+          </a:stretch>
+        </p:blipFill>
+        <p:spPr>
+          <a:xfrm>
+            <a:off x="1" y="4093782"/>
+            <a:ext cx="5449078" cy="2764217"/>
+          </a:xfrm>
+          <a:prstGeom prst="rect">
+            <a:avLst/>
+          </a:prstGeom>
+        </p:spPr>
+      </p:pic>
+    </p:spTree>
+    <p:extLst>
+      <p:ext uri="{BB962C8B-B14F-4D97-AF65-F5344CB8AC3E}">
+        <p14:creationId xmlns:p14="http://schemas.microsoft.com/office/powerpoint/2010/main" val="2772987961"/>
+      </p:ext>
+    </p:extLst>
+  </p:cSld>
+  <p:clrMapOvr>
+    <a:masterClrMapping/>
+  </p:clrMapOvr>
+</p:sld>
+</file>
+
+<file path=ppt/slides/slide24.xml><?xml version="1.0" encoding="utf-8"?>
+<p:sld xmlns:a="http://schemas.openxmlformats.org/drawingml/2006/main" xmlns:r="http://schemas.openxmlformats.org/officeDocument/2006/relationships" xmlns:p="http://schemas.openxmlformats.org/presentationml/2006/main">
+  <p:cSld>
+    <p:spTree>
+      <p:nvGrpSpPr>
+        <p:cNvPr id="1" name="">
+          <a:extLst>
+            <a:ext uri="{FF2B5EF4-FFF2-40B4-BE49-F238E27FC236}">
+              <a16:creationId xmlns:a16="http://schemas.microsoft.com/office/drawing/2014/main" id="{B8E6061D-9E9D-E716-6824-07CA532DBCBF}"/>
+            </a:ext>
+          </a:extLst>
+        </p:cNvPr>
+        <p:cNvGrpSpPr/>
+        <p:nvPr/>
+      </p:nvGrpSpPr>
+      <p:grpSpPr>
+        <a:xfrm>
+          <a:off x="0" y="0"/>
+          <a:ext cx="0" cy="0"/>
+          <a:chOff x="0" y="0"/>
+          <a:chExt cx="0" cy="0"/>
+        </a:xfrm>
+      </p:grpSpPr>
+      <p:sp>
+        <p:nvSpPr>
+          <p:cNvPr id="3" name="TextBox 2">
+            <a:extLst>
+              <a:ext uri="{FF2B5EF4-FFF2-40B4-BE49-F238E27FC236}">
+                <a16:creationId xmlns:a16="http://schemas.microsoft.com/office/drawing/2014/main" id="{DD16A92E-DE65-3EEE-B691-B2488A61350A}"/>
+              </a:ext>
+            </a:extLst>
+          </p:cNvPr>
+          <p:cNvSpPr txBox="1"/>
+          <p:nvPr/>
+        </p:nvSpPr>
+        <p:spPr>
+          <a:xfrm>
+            <a:off x="217714" y="255046"/>
+            <a:ext cx="11756571" cy="355354"/>
+          </a:xfrm>
+          <a:prstGeom prst="rect">
+            <a:avLst/>
+          </a:prstGeom>
+          <a:noFill/>
+        </p:spPr>
+        <p:txBody>
+          <a:bodyPr wrap="square">
+            <a:spAutoFit/>
+          </a:bodyPr>
+          <a:lstStyle/>
+          <a:p>
+            <a:pPr>
+              <a:lnSpc>
+                <a:spcPct val="150000"/>
+              </a:lnSpc>
+              <a:buNone/>
+            </a:pPr>
+            <a:r>
+              <a:rPr lang="az-Latn-AZ" altLang="en-US" sz="1300">
+                <a:latin typeface="Arial" panose="020B0604020202020204" pitchFamily="34" charset="0"/>
+              </a:rPr>
+              <a:t>Nəticə....</a:t>
+            </a:r>
+            <a:endParaRPr kumimoji="0" lang="en-US" altLang="en-US" sz="1300" b="0" i="0" u="none" strike="noStrike" cap="none" normalizeH="0" baseline="0">
+              <a:ln>
+                <a:noFill/>
+              </a:ln>
+              <a:solidFill>
+                <a:schemeClr val="tx1"/>
+              </a:solidFill>
+              <a:effectLst/>
+              <a:latin typeface="Arial" panose="020B0604020202020204" pitchFamily="34" charset="0"/>
+            </a:endParaRPr>
+          </a:p>
+        </p:txBody>
+      </p:sp>
+      <p:pic>
+        <p:nvPicPr>
+          <p:cNvPr id="4" name="Picture 3">
+            <a:extLst>
+              <a:ext uri="{FF2B5EF4-FFF2-40B4-BE49-F238E27FC236}">
+                <a16:creationId xmlns:a16="http://schemas.microsoft.com/office/drawing/2014/main" id="{5902143B-3A4C-6C06-E723-EE8F00DE4734}"/>
+              </a:ext>
+            </a:extLst>
+          </p:cNvPr>
+          <p:cNvPicPr>
+            <a:picLocks noChangeAspect="1"/>
+          </p:cNvPicPr>
+          <p:nvPr/>
+        </p:nvPicPr>
+        <p:blipFill>
+          <a:blip r:embed="rId2"/>
+          <a:stretch>
+            <a:fillRect/>
+          </a:stretch>
+        </p:blipFill>
+        <p:spPr>
+          <a:xfrm>
+            <a:off x="-1" y="786471"/>
+            <a:ext cx="12192000" cy="2493239"/>
+          </a:xfrm>
+          <a:prstGeom prst="rect">
+            <a:avLst/>
+          </a:prstGeom>
+          <a:ln w="38100" cap="sq">
+            <a:solidFill>
+              <a:srgbClr val="000000"/>
+            </a:solidFill>
+            <a:prstDash val="solid"/>
+            <a:miter lim="800000"/>
+          </a:ln>
+          <a:effectLst>
+            <a:outerShdw blurRad="50800" dist="38100" dir="2700000" algn="tl" rotWithShape="0">
+              <a:srgbClr val="000000">
+                <a:alpha val="43000"/>
+              </a:srgbClr>
+            </a:outerShdw>
+          </a:effectLst>
+        </p:spPr>
+      </p:pic>
+      <p:pic>
+        <p:nvPicPr>
+          <p:cNvPr id="6" name="Picture 5">
+            <a:extLst>
+              <a:ext uri="{FF2B5EF4-FFF2-40B4-BE49-F238E27FC236}">
+                <a16:creationId xmlns:a16="http://schemas.microsoft.com/office/drawing/2014/main" id="{BBEEF186-2284-B92F-5F18-176F4D9D3ECC}"/>
+              </a:ext>
+            </a:extLst>
+          </p:cNvPr>
+          <p:cNvPicPr>
+            <a:picLocks noChangeAspect="1"/>
+          </p:cNvPicPr>
+          <p:nvPr/>
+        </p:nvPicPr>
+        <p:blipFill>
+          <a:blip r:embed="rId3"/>
+          <a:stretch>
+            <a:fillRect/>
+          </a:stretch>
+        </p:blipFill>
+        <p:spPr>
+          <a:xfrm>
+            <a:off x="0" y="3797559"/>
+            <a:ext cx="8647043" cy="3060441"/>
+          </a:xfrm>
+          <a:prstGeom prst="rect">
+            <a:avLst/>
+          </a:prstGeom>
+        </p:spPr>
+      </p:pic>
+    </p:spTree>
+    <p:extLst>
+      <p:ext uri="{BB962C8B-B14F-4D97-AF65-F5344CB8AC3E}">
+        <p14:creationId xmlns:p14="http://schemas.microsoft.com/office/powerpoint/2010/main" val="605528789"/>
+      </p:ext>
+    </p:extLst>
+  </p:cSld>
+  <p:clrMapOvr>
+    <a:masterClrMapping/>
+  </p:clrMapOvr>
+</p:sld>
+</file>
+
+<file path=ppt/slides/slide25.xml><?xml version="1.0" encoding="utf-8"?>
+<p:sld xmlns:a="http://schemas.openxmlformats.org/drawingml/2006/main" xmlns:r="http://schemas.openxmlformats.org/officeDocument/2006/relationships" xmlns:p="http://schemas.openxmlformats.org/presentationml/2006/main">
+  <p:cSld>
+    <p:spTree>
+      <p:nvGrpSpPr>
+        <p:cNvPr id="1" name="">
+          <a:extLst>
+            <a:ext uri="{FF2B5EF4-FFF2-40B4-BE49-F238E27FC236}">
+              <a16:creationId xmlns:a16="http://schemas.microsoft.com/office/drawing/2014/main" id="{A0E8433B-338B-DAEA-B8B5-860DD85BB668}"/>
+            </a:ext>
+          </a:extLst>
+        </p:cNvPr>
+        <p:cNvGrpSpPr/>
+        <p:nvPr/>
+      </p:nvGrpSpPr>
+      <p:grpSpPr>
+        <a:xfrm>
+          <a:off x="0" y="0"/>
+          <a:ext cx="0" cy="0"/>
+          <a:chOff x="0" y="0"/>
+          <a:chExt cx="0" cy="0"/>
+        </a:xfrm>
+      </p:grpSpPr>
+      <p:sp>
+        <p:nvSpPr>
+          <p:cNvPr id="3" name="TextBox 2">
+            <a:extLst>
+              <a:ext uri="{FF2B5EF4-FFF2-40B4-BE49-F238E27FC236}">
+                <a16:creationId xmlns:a16="http://schemas.microsoft.com/office/drawing/2014/main" id="{F7CB1601-D406-1BF7-4469-992D3AF57941}"/>
+              </a:ext>
+            </a:extLst>
+          </p:cNvPr>
+          <p:cNvSpPr txBox="1"/>
+          <p:nvPr/>
+        </p:nvSpPr>
+        <p:spPr>
+          <a:xfrm>
+            <a:off x="217714" y="255046"/>
+            <a:ext cx="11756571" cy="355354"/>
+          </a:xfrm>
+          <a:prstGeom prst="rect">
+            <a:avLst/>
+          </a:prstGeom>
+          <a:noFill/>
+        </p:spPr>
+        <p:txBody>
+          <a:bodyPr wrap="square">
+            <a:spAutoFit/>
+          </a:bodyPr>
+          <a:lstStyle/>
+          <a:p>
+            <a:pPr>
+              <a:lnSpc>
+                <a:spcPct val="150000"/>
+              </a:lnSpc>
+              <a:buNone/>
+            </a:pPr>
+            <a:r>
+              <a:rPr kumimoji="0" lang="en-US" altLang="en-US" sz="1300" b="0" i="0" u="none" strike="noStrike" cap="none" normalizeH="0" baseline="0">
+                <a:ln>
+                  <a:noFill/>
+                </a:ln>
+                <a:solidFill>
+                  <a:schemeClr val="tx1"/>
+                </a:solidFill>
+                <a:effectLst/>
+                <a:latin typeface="Arial" panose="020B0604020202020204" pitchFamily="34" charset="0"/>
+              </a:rPr>
+              <a:t>.</a:t>
+            </a:r>
+          </a:p>
+        </p:txBody>
+      </p:sp>
+    </p:spTree>
+    <p:extLst>
+      <p:ext uri="{BB962C8B-B14F-4D97-AF65-F5344CB8AC3E}">
+        <p14:creationId xmlns:p14="http://schemas.microsoft.com/office/powerpoint/2010/main" val="3631706994"/>
+      </p:ext>
+    </p:extLst>
+  </p:cSld>
+  <p:clrMapOvr>
+    <a:masterClrMapping/>
+  </p:clrMapOvr>
+</p:sld>
+</file>
+
+<file path=ppt/slides/slide26.xml><?xml version="1.0" encoding="utf-8"?>
+<p:sld xmlns:a="http://schemas.openxmlformats.org/drawingml/2006/main" xmlns:r="http://schemas.openxmlformats.org/officeDocument/2006/relationships" xmlns:p="http://schemas.openxmlformats.org/presentationml/2006/main">
+  <p:cSld>
+    <p:spTree>
+      <p:nvGrpSpPr>
+        <p:cNvPr id="1" name="">
+          <a:extLst>
+            <a:ext uri="{FF2B5EF4-FFF2-40B4-BE49-F238E27FC236}">
+              <a16:creationId xmlns:a16="http://schemas.microsoft.com/office/drawing/2014/main" id="{7FF4C2B8-6ABD-298A-A51C-0A09C2AC80F9}"/>
+            </a:ext>
+          </a:extLst>
+        </p:cNvPr>
+        <p:cNvGrpSpPr/>
+        <p:nvPr/>
+      </p:nvGrpSpPr>
+      <p:grpSpPr>
+        <a:xfrm>
+          <a:off x="0" y="0"/>
+          <a:ext cx="0" cy="0"/>
+          <a:chOff x="0" y="0"/>
+          <a:chExt cx="0" cy="0"/>
+        </a:xfrm>
+      </p:grpSpPr>
+      <p:sp>
+        <p:nvSpPr>
+          <p:cNvPr id="3" name="TextBox 2">
+            <a:extLst>
+              <a:ext uri="{FF2B5EF4-FFF2-40B4-BE49-F238E27FC236}">
+                <a16:creationId xmlns:a16="http://schemas.microsoft.com/office/drawing/2014/main" id="{DEE0DC95-9EDC-608A-D71C-0906D5D52A6E}"/>
+              </a:ext>
+            </a:extLst>
+          </p:cNvPr>
+          <p:cNvSpPr txBox="1"/>
+          <p:nvPr/>
+        </p:nvSpPr>
+        <p:spPr>
+          <a:xfrm>
+            <a:off x="217714" y="255046"/>
+            <a:ext cx="11756571" cy="355354"/>
+          </a:xfrm>
+          <a:prstGeom prst="rect">
+            <a:avLst/>
+          </a:prstGeom>
+          <a:noFill/>
+        </p:spPr>
+        <p:txBody>
+          <a:bodyPr wrap="square">
+            <a:spAutoFit/>
+          </a:bodyPr>
+          <a:lstStyle/>
+          <a:p>
+            <a:pPr>
+              <a:lnSpc>
+                <a:spcPct val="150000"/>
+              </a:lnSpc>
+              <a:buNone/>
+            </a:pPr>
+            <a:r>
+              <a:rPr kumimoji="0" lang="en-US" altLang="en-US" sz="1300" b="0" i="0" u="none" strike="noStrike" cap="none" normalizeH="0" baseline="0">
+                <a:ln>
+                  <a:noFill/>
+                </a:ln>
+                <a:solidFill>
+                  <a:schemeClr val="tx1"/>
+                </a:solidFill>
+                <a:effectLst/>
+                <a:latin typeface="Arial" panose="020B0604020202020204" pitchFamily="34" charset="0"/>
+              </a:rPr>
+              <a:t>.</a:t>
+            </a:r>
+          </a:p>
+        </p:txBody>
+      </p:sp>
+    </p:spTree>
+    <p:extLst>
+      <p:ext uri="{BB962C8B-B14F-4D97-AF65-F5344CB8AC3E}">
+        <p14:creationId xmlns:p14="http://schemas.microsoft.com/office/powerpoint/2010/main" val="1406546416"/>
+      </p:ext>
+    </p:extLst>
+  </p:cSld>
+  <p:clrMapOvr>
+    <a:masterClrMapping/>
+  </p:clrMapOvr>
+</p:sld>
+</file>
+
+<file path=ppt/slides/slide27.xml><?xml version="1.0" encoding="utf-8"?>
+<p:sld xmlns:a="http://schemas.openxmlformats.org/drawingml/2006/main" xmlns:r="http://schemas.openxmlformats.org/officeDocument/2006/relationships" xmlns:p="http://schemas.openxmlformats.org/presentationml/2006/main">
+  <p:cSld>
+    <p:spTree>
+      <p:nvGrpSpPr>
+        <p:cNvPr id="1" name="">
+          <a:extLst>
+            <a:ext uri="{FF2B5EF4-FFF2-40B4-BE49-F238E27FC236}">
+              <a16:creationId xmlns:a16="http://schemas.microsoft.com/office/drawing/2014/main" id="{A2506587-490C-7C61-1F61-C2106CCEB092}"/>
+            </a:ext>
+          </a:extLst>
+        </p:cNvPr>
+        <p:cNvGrpSpPr/>
+        <p:nvPr/>
+      </p:nvGrpSpPr>
+      <p:grpSpPr>
+        <a:xfrm>
+          <a:off x="0" y="0"/>
+          <a:ext cx="0" cy="0"/>
+          <a:chOff x="0" y="0"/>
+          <a:chExt cx="0" cy="0"/>
+        </a:xfrm>
+      </p:grpSpPr>
+      <p:sp>
+        <p:nvSpPr>
+          <p:cNvPr id="3" name="TextBox 2">
+            <a:extLst>
+              <a:ext uri="{FF2B5EF4-FFF2-40B4-BE49-F238E27FC236}">
+                <a16:creationId xmlns:a16="http://schemas.microsoft.com/office/drawing/2014/main" id="{6B8412FD-760B-2AE4-4872-A59438CF723F}"/>
+              </a:ext>
+            </a:extLst>
+          </p:cNvPr>
+          <p:cNvSpPr txBox="1"/>
+          <p:nvPr/>
+        </p:nvSpPr>
+        <p:spPr>
+          <a:xfrm>
+            <a:off x="217714" y="255046"/>
+            <a:ext cx="11756571" cy="355354"/>
+          </a:xfrm>
+          <a:prstGeom prst="rect">
+            <a:avLst/>
+          </a:prstGeom>
+          <a:noFill/>
+        </p:spPr>
+        <p:txBody>
+          <a:bodyPr wrap="square">
+            <a:spAutoFit/>
+          </a:bodyPr>
+          <a:lstStyle/>
+          <a:p>
+            <a:pPr>
+              <a:lnSpc>
+                <a:spcPct val="150000"/>
+              </a:lnSpc>
+              <a:buNone/>
+            </a:pPr>
+            <a:r>
+              <a:rPr kumimoji="0" lang="en-US" altLang="en-US" sz="1300" b="0" i="0" u="none" strike="noStrike" cap="none" normalizeH="0" baseline="0">
+                <a:ln>
+                  <a:noFill/>
+                </a:ln>
+                <a:solidFill>
+                  <a:schemeClr val="tx1"/>
+                </a:solidFill>
+                <a:effectLst/>
+                <a:latin typeface="Arial" panose="020B0604020202020204" pitchFamily="34" charset="0"/>
+              </a:rPr>
+              <a:t>.</a:t>
+            </a:r>
+          </a:p>
+        </p:txBody>
+      </p:sp>
+    </p:spTree>
+    <p:extLst>
+      <p:ext uri="{BB962C8B-B14F-4D97-AF65-F5344CB8AC3E}">
+        <p14:creationId xmlns:p14="http://schemas.microsoft.com/office/powerpoint/2010/main" val="324630331"/>
       </p:ext>
     </p:extLst>
   </p:cSld>

</xml_diff>